<commit_message>
docs: show order, Dark Vessels closes; deck, rehearsal notes and roadmap reordered
Running order (decided Oct 21): Earth Analyst (Act 1), AI Archaeologist (Act 4), Methane Watch (Act 2), Dark Vessels (Act 3) as the closer; act numbers unchanged. Fallback if Act 3 misses gate B (Wed Oct 28 12:00): Methane Watch closes, Act 3 cut or its four-turn version third. Rehearsal notes: sections in show order with clocks recomputed (30 min), plate tables matched to stageCopy.ts (Bergen, Octagon wall, new methane and Great Circle plates), Act 3 outlined as the closer with the second-screen Slack post, close script and fallback lines. Deck: slide 3 in show order, notes on slides 2 to 5. ROADMAP and the Act 4 run sheet heading no longer call Act 4 the closer.
</commit_message>
<xml_diff>
--- a/docs/demo/agentic-ai-for-earth-intro.pptx
+++ b/docs/demo/agentic-ai-for-earth-intro.pptx
@@ -681,7 +681,7 @@
                 <a:ea typeface="Atkinson Hyperlegible"/>
                 <a:cs typeface="Atkinson Hyperlegible"/>
               </a:rPr>
-              <a:t>Here’s the problem. We collect more Earth observation data than people can read. In Act 1, one question compares about 190,000 patches of New York State. In Act 2, the agent scans nine methane watch areas with one sensor in orbit, then checks the strongest with a sharper one. In Act 3, around a hundred vessels an hour broadcast inside one marine reserve. Nobody reads all that by hand. So the agent does the reading and the legwork, and shows its evidence. A person makes the call.</a:t>
+              <a:t>Here’s the problem. We collect more Earth observation data than people can read. In the first act, one question compares about 190,000 patches of New York State. In the methane act, the agent scans nine watch areas with one sensor in orbit, then checks the strongest with a sharper one. In the last act, around a hundred vessels an hour broadcast inside one marine reserve. Nobody reads all that by hand. So the agent does the reading and the legwork, and shows its evidence. A person makes the call.</a:t>
             </a:r>
           </a:p>
           <a:p>
@@ -815,7 +815,7 @@
                 <a:ea typeface="Atkinson Hyperlegible"/>
                 <a:cs typeface="Atkinson Hyperlegible"/>
               </a:rPr>
-              <a:t>Act 1, the Earth Analyst, finds a place, fetches a Sentinel-2 scene, looks at it, then measures plant health or water, or finds similar places. Act 2, the Methane Hunter, follows a satellite tip to a methane site, checks ground records and drafts a brief for an analyst. Act 3, Dark Vessels, compares a radar pass over the Galápagos with ship broadcasts, called AIS, and checks where those broadcasts can be heard. A silent target there is a candidate for a patrol, never an accusation. Act 4, the AI Archaeologist, reads LiDAR of earthworks already on the public record, and only those.</a:t>
+              <a:t>First, the Earth Analyst fetches a Sentinel-2 scene, looks at it, then measures plant health or finds similar places. Second, the AI Archaeologist reads LiDAR of earthworks already on the public record, and only those. Third, the Methane Hunter follows a satellite tip to a methane site, checks ground records and drafts a brief for an analyst. Last, Dark Vessels compares a radar pass over the Galápagos with ship broadcasts, called AIS, and checks where those broadcasts can be heard. A silent target there is a candidate for a patrol, never an accusation.</a:t>
             </a:r>
           </a:p>
           <a:p>
@@ -949,7 +949,7 @@
                 <a:ea typeface="Atkinson Hyperlegible"/>
                 <a:cs typeface="Atkinson Hyperlegible"/>
               </a:rPr>
-              <a:t>Each agent is its own runtime on Amazon Bedrock AgentCore. A foundation model, Claude Sonnet 4.6 by default, reads the question and calls the agent’s tools, sometimes several at once: fetch a scene, compute an index, check a record. How freely it chooses varies: the Earth Analyst picks its own tools, dates and scenes; the archaeologist follows a set path over prepared LiDAR. All four share one map stage, drawn with MapLibre, an open-source map library, with session files in Amazon S3. The analyst files the brief and the officer approves the tasking; the backend enforces that, not the model.</a:t>
+              <a:t>Each agent is its own runtime on Amazon Bedrock AgentCore. A foundation model, Claude Sonnet 4.6 by default, reads the question and calls the agent’s tools, sometimes several at once: fetch a scene, compute an index, check a record. How freely it chooses varies: the Earth Analyst picks its own tools, dates and scenes; the archaeologist works over prepared LiDAR but picks the line it measures. All four share one map stage, with session files in Amazon S3. The analyst files the brief and the officer approves the tasking; the backend enforces that, not the model.</a:t>
             </a:r>
           </a:p>
           <a:p>
@@ -1060,7 +1060,7 @@
                 <a:ea typeface="Atkinson Hyperlegible"/>
                 <a:cs typeface="Atkinson Hyperlegible"/>
               </a:rPr>
-              <a:t>Steps, evidence, and nothing filed until a person approves.</a:t>
+              <a:t>Steps, evidence, and nothing filed until a person approves; the show ends on the officer’s call.</a:t>
             </a:r>
           </a:p>
           <a:p>
@@ -1083,7 +1083,7 @@
                 <a:ea typeface="Atkinson Hyperlegible"/>
                 <a:cs typeface="Atkinson Hyperlegible"/>
               </a:rPr>
-              <a:t>Three things to watch. On the left, the agent’s steps, numbered and lit one at a time, with the images it looked at. In the middle, the map: each layer it lands is evidence you can check. And the moment a person decides. In the methane act, I’ll play the analyst and decide whether to file the draft brief. In the vessels act, I’ll play the officer and decide whether to approve the patrol tasking. Some steps take thirty seconds or more; that’s the agent working.</a:t>
+              <a:t>Three things to watch. On the left, the agent’s steps, lit one at a time, with the images it looked at. In the middle, the map: each layer it lands is evidence you can check. And the moment a person decides. In the methane act, I’ll play the analyst and decide whether to file the draft brief. The last act, Dark Vessels, ends on the agent’s own choices, each with its reason, then a prediction of where to look next, checked against past radar days, and a draft patrol tasking. I’ll play the officer and decide whether to approve it.</a:t>
             </a:r>
           </a:p>
           <a:p>
@@ -4921,6 +4921,173 @@
       </p:sp>
       <p:pic>
         <p:nvPicPr>
+          <p:cNvPr id="15" name="Act 4 screenshot" descr="AI Archaeologist on the stage: 1 m LiDAR hillshade of the Newark Octagon and Great Circle, a World Heritage site."/>
+          <p:cNvPicPr>
+            <a:picLocks noChangeAspect="1"/>
+          </p:cNvPicPr>
+          <p:nvPr/>
+        </p:nvPicPr>
+        <p:blipFill>
+          <a:blip r:embed="rId5"/>
+          <a:stretch>
+            <a:fillRect/>
+          </a:stretch>
+        </p:blipFill>
+        <p:spPr>
+          <a:xfrm>
+            <a:off x="3463975" y="2057400"/>
+            <a:ext cx="2531287" cy="1855334"/>
+          </a:xfrm>
+          <a:prstGeom prst="roundRect">
+            <a:avLst>
+              <a:gd name="adj" fmla="val 3500"/>
+            </a:avLst>
+          </a:prstGeom>
+          <a:ln w="12700">
+            <a:solidFill>
+              <a:srgbClr val="43484F"/>
+            </a:solidFill>
+          </a:ln>
+        </p:spPr>
+      </p:pic>
+      <p:sp>
+        <p:nvSpPr>
+          <p:cNvPr id="16" name="Act 4 number"/>
+          <p:cNvSpPr/>
+          <p:nvPr/>
+        </p:nvSpPr>
+        <p:spPr>
+          <a:xfrm>
+            <a:off x="3564559" y="2157984"/>
+            <a:ext cx="384048" cy="384048"/>
+          </a:xfrm>
+          <a:prstGeom prst="ellipse">
+            <a:avLst/>
+          </a:prstGeom>
+          <a:solidFill>
+            <a:srgbClr val="1D2530"/>
+          </a:solidFill>
+          <a:ln w="12700">
+            <a:solidFill>
+              <a:srgbClr val="43484F"/>
+            </a:solidFill>
+          </a:ln>
+        </p:spPr>
+        <p:txBody>
+          <a:bodyPr rtlCol="0" anchor="ctr" lIns="0" rIns="0" tIns="0" bIns="0" wrap="none"/>
+          <a:lstStyle/>
+          <a:p>
+            <a:pPr algn="ctr"/>
+            <a:r>
+              <a:rPr sz="2000" b="1" lang="en-GB">
+                <a:solidFill>
+                  <a:srgbClr val="E9EEF3"/>
+                </a:solidFill>
+                <a:latin typeface="Menlo"/>
+                <a:ea typeface="Menlo"/>
+                <a:cs typeface="Menlo"/>
+              </a:rPr>
+              <a:t>2</a:t>
+            </a:r>
+          </a:p>
+        </p:txBody>
+      </p:sp>
+      <p:sp>
+        <p:nvSpPr>
+          <p:cNvPr id="17" name="Act 4 name"/>
+          <p:cNvSpPr txBox="1"/>
+          <p:nvPr/>
+        </p:nvSpPr>
+        <p:spPr>
+          <a:xfrm>
+            <a:off x="3463975" y="4168766"/>
+            <a:ext cx="2531287" cy="420624"/>
+          </a:xfrm>
+          <a:prstGeom prst="rect">
+            <a:avLst/>
+          </a:prstGeom>
+          <a:noFill/>
+        </p:spPr>
+        <p:txBody>
+          <a:bodyPr wrap="square" lIns="0" rIns="0" tIns="0" bIns="0" anchor="t">
+            <a:noAutofit/>
+          </a:bodyPr>
+          <a:lstStyle/>
+          <a:p>
+            <a:pPr algn="l">
+              <a:lnSpc>
+                <a:spcPct val="110000"/>
+              </a:lnSpc>
+              <a:spcBef>
+                <a:spcPts val="0"/>
+              </a:spcBef>
+              <a:spcAft>
+                <a:spcPts val="0"/>
+              </a:spcAft>
+            </a:pPr>
+            <a:r>
+              <a:rPr sz="2400" b="1" lang="en-GB">
+                <a:solidFill>
+                  <a:srgbClr val="E9EEF3"/>
+                </a:solidFill>
+                <a:latin typeface="Atkinson Hyperlegible"/>
+                <a:ea typeface="Atkinson Hyperlegible"/>
+                <a:cs typeface="Atkinson Hyperlegible"/>
+              </a:rPr>
+              <a:t>AI Archaeologist</a:t>
+            </a:r>
+          </a:p>
+        </p:txBody>
+      </p:sp>
+      <p:sp>
+        <p:nvSpPr>
+          <p:cNvPr id="18" name="Act 4 line"/>
+          <p:cNvSpPr txBox="1"/>
+          <p:nvPr/>
+        </p:nvSpPr>
+        <p:spPr>
+          <a:xfrm>
+            <a:off x="3463975" y="4671686"/>
+            <a:ext cx="2531287" cy="1005840"/>
+          </a:xfrm>
+          <a:prstGeom prst="rect">
+            <a:avLst/>
+          </a:prstGeom>
+          <a:noFill/>
+        </p:spPr>
+        <p:txBody>
+          <a:bodyPr wrap="square" lIns="0" rIns="0" tIns="0" bIns="0" anchor="t">
+            <a:noAutofit/>
+          </a:bodyPr>
+          <a:lstStyle/>
+          <a:p>
+            <a:pPr algn="l">
+              <a:lnSpc>
+                <a:spcPct val="105000"/>
+              </a:lnSpc>
+              <a:spcBef>
+                <a:spcPts val="0"/>
+              </a:spcBef>
+              <a:spcAft>
+                <a:spcPts val="0"/>
+              </a:spcAft>
+            </a:pPr>
+            <a:r>
+              <a:rPr sz="2000" b="0" lang="en-GB">
+                <a:solidFill>
+                  <a:srgbClr val="E9EEF3"/>
+                </a:solidFill>
+                <a:latin typeface="Atkinson Hyperlegible"/>
+                <a:ea typeface="Atkinson Hyperlegible"/>
+                <a:cs typeface="Atkinson Hyperlegible"/>
+              </a:rPr>
+              <a:t>LiDAR of known, public sites</a:t>
+            </a:r>
+          </a:p>
+        </p:txBody>
+      </p:sp>
+      <p:pic>
+        <p:nvPicPr>
           <p:cNvPr id="7" name="Act 2 screenshot" descr="Methane Hunter on the stage: a globe in space with repeat methane sites as dots and rings, and dashed watch-area outlines."/>
           <p:cNvPicPr>
             <a:picLocks noChangeAspect="1"/>
@@ -4935,7 +5102,7 @@
         </p:blipFill>
         <p:spPr>
           <a:xfrm>
-            <a:off x="3463975" y="2057400"/>
+            <a:off x="6196431" y="2057400"/>
             <a:ext cx="2531287" cy="1855334"/>
           </a:xfrm>
           <a:prstGeom prst="roundRect">
@@ -4958,7 +5125,7 @@
         </p:nvSpPr>
         <p:spPr>
           <a:xfrm>
-            <a:off x="3564559" y="2157984"/>
+            <a:off x="6297015" y="2157984"/>
             <a:ext cx="384048" cy="384048"/>
           </a:xfrm>
           <a:prstGeom prst="ellipse">
@@ -4987,7 +5154,7 @@
                 <a:ea typeface="Menlo"/>
                 <a:cs typeface="Menlo"/>
               </a:rPr>
-              <a:t>2</a:t>
+              <a:t>3</a:t>
             </a:r>
           </a:p>
         </p:txBody>
@@ -5000,7 +5167,7 @@
         </p:nvSpPr>
         <p:spPr>
           <a:xfrm>
-            <a:off x="3463975" y="4168766"/>
+            <a:off x="6196431" y="4168766"/>
             <a:ext cx="2531287" cy="420624"/>
           </a:xfrm>
           <a:prstGeom prst="rect">
@@ -5047,7 +5214,7 @@
         </p:nvSpPr>
         <p:spPr>
           <a:xfrm>
-            <a:off x="3463975" y="4671686"/>
+            <a:off x="6196431" y="4671686"/>
             <a:ext cx="2531287" cy="1005840"/>
           </a:xfrm>
           <a:prstGeom prst="rect">
@@ -5102,7 +5269,7 @@
         </p:blipFill>
         <p:spPr>
           <a:xfrm>
-            <a:off x="6196431" y="2057400"/>
+            <a:off x="8928887" y="2057400"/>
             <a:ext cx="2531287" cy="1855334"/>
           </a:xfrm>
           <a:prstGeom prst="roundRect">
@@ -5125,7 +5292,7 @@
         </p:nvSpPr>
         <p:spPr>
           <a:xfrm>
-            <a:off x="6297015" y="2157984"/>
+            <a:off x="9029471" y="2157984"/>
             <a:ext cx="384048" cy="384048"/>
           </a:xfrm>
           <a:prstGeom prst="ellipse">
@@ -5154,7 +5321,7 @@
                 <a:ea typeface="Menlo"/>
                 <a:cs typeface="Menlo"/>
               </a:rPr>
-              <a:t>3</a:t>
+              <a:t>4</a:t>
             </a:r>
           </a:p>
         </p:txBody>
@@ -5167,7 +5334,7 @@
         </p:nvSpPr>
         <p:spPr>
           <a:xfrm>
-            <a:off x="6196431" y="4168766"/>
+            <a:off x="8928887" y="4168766"/>
             <a:ext cx="2531287" cy="420624"/>
           </a:xfrm>
           <a:prstGeom prst="rect">
@@ -5214,7 +5381,7 @@
         </p:nvSpPr>
         <p:spPr>
           <a:xfrm>
-            <a:off x="6196431" y="4671686"/>
+            <a:off x="8928887" y="4671686"/>
             <a:ext cx="2531287" cy="1005840"/>
           </a:xfrm>
           <a:prstGeom prst="rect">
@@ -5249,173 +5416,6 @@
                 <a:cs typeface="Atkinson Hyperlegible"/>
               </a:rPr>
               <a:t>Radar candidates, never accusations</a:t>
-            </a:r>
-          </a:p>
-        </p:txBody>
-      </p:sp>
-      <p:pic>
-        <p:nvPicPr>
-          <p:cNvPr id="15" name="Act 4 screenshot" descr="AI Archaeologist on the stage: 1 m LiDAR hillshade of the Newark Octagon and Great Circle, a World Heritage site."/>
-          <p:cNvPicPr>
-            <a:picLocks noChangeAspect="1"/>
-          </p:cNvPicPr>
-          <p:nvPr/>
-        </p:nvPicPr>
-        <p:blipFill>
-          <a:blip r:embed="rId5"/>
-          <a:stretch>
-            <a:fillRect/>
-          </a:stretch>
-        </p:blipFill>
-        <p:spPr>
-          <a:xfrm>
-            <a:off x="8928887" y="2057400"/>
-            <a:ext cx="2531287" cy="1855334"/>
-          </a:xfrm>
-          <a:prstGeom prst="roundRect">
-            <a:avLst>
-              <a:gd name="adj" fmla="val 3500"/>
-            </a:avLst>
-          </a:prstGeom>
-          <a:ln w="12700">
-            <a:solidFill>
-              <a:srgbClr val="43484F"/>
-            </a:solidFill>
-          </a:ln>
-        </p:spPr>
-      </p:pic>
-      <p:sp>
-        <p:nvSpPr>
-          <p:cNvPr id="16" name="Act 4 number"/>
-          <p:cNvSpPr/>
-          <p:nvPr/>
-        </p:nvSpPr>
-        <p:spPr>
-          <a:xfrm>
-            <a:off x="9029471" y="2157984"/>
-            <a:ext cx="384048" cy="384048"/>
-          </a:xfrm>
-          <a:prstGeom prst="ellipse">
-            <a:avLst/>
-          </a:prstGeom>
-          <a:solidFill>
-            <a:srgbClr val="1D2530"/>
-          </a:solidFill>
-          <a:ln w="12700">
-            <a:solidFill>
-              <a:srgbClr val="43484F"/>
-            </a:solidFill>
-          </a:ln>
-        </p:spPr>
-        <p:txBody>
-          <a:bodyPr rtlCol="0" anchor="ctr" lIns="0" rIns="0" tIns="0" bIns="0" wrap="none"/>
-          <a:lstStyle/>
-          <a:p>
-            <a:pPr algn="ctr"/>
-            <a:r>
-              <a:rPr sz="2000" b="1" lang="en-GB">
-                <a:solidFill>
-                  <a:srgbClr val="E9EEF3"/>
-                </a:solidFill>
-                <a:latin typeface="Menlo"/>
-                <a:ea typeface="Menlo"/>
-                <a:cs typeface="Menlo"/>
-              </a:rPr>
-              <a:t>4</a:t>
-            </a:r>
-          </a:p>
-        </p:txBody>
-      </p:sp>
-      <p:sp>
-        <p:nvSpPr>
-          <p:cNvPr id="17" name="Act 4 name"/>
-          <p:cNvSpPr txBox="1"/>
-          <p:nvPr/>
-        </p:nvSpPr>
-        <p:spPr>
-          <a:xfrm>
-            <a:off x="8928887" y="4168766"/>
-            <a:ext cx="2531287" cy="420624"/>
-          </a:xfrm>
-          <a:prstGeom prst="rect">
-            <a:avLst/>
-          </a:prstGeom>
-          <a:noFill/>
-        </p:spPr>
-        <p:txBody>
-          <a:bodyPr wrap="square" lIns="0" rIns="0" tIns="0" bIns="0" anchor="t">
-            <a:noAutofit/>
-          </a:bodyPr>
-          <a:lstStyle/>
-          <a:p>
-            <a:pPr algn="l">
-              <a:lnSpc>
-                <a:spcPct val="110000"/>
-              </a:lnSpc>
-              <a:spcBef>
-                <a:spcPts val="0"/>
-              </a:spcBef>
-              <a:spcAft>
-                <a:spcPts val="0"/>
-              </a:spcAft>
-            </a:pPr>
-            <a:r>
-              <a:rPr sz="2400" b="1" lang="en-GB">
-                <a:solidFill>
-                  <a:srgbClr val="E9EEF3"/>
-                </a:solidFill>
-                <a:latin typeface="Atkinson Hyperlegible"/>
-                <a:ea typeface="Atkinson Hyperlegible"/>
-                <a:cs typeface="Atkinson Hyperlegible"/>
-              </a:rPr>
-              <a:t>AI Archaeologist</a:t>
-            </a:r>
-          </a:p>
-        </p:txBody>
-      </p:sp>
-      <p:sp>
-        <p:nvSpPr>
-          <p:cNvPr id="18" name="Act 4 line"/>
-          <p:cNvSpPr txBox="1"/>
-          <p:nvPr/>
-        </p:nvSpPr>
-        <p:spPr>
-          <a:xfrm>
-            <a:off x="8928887" y="4671686"/>
-            <a:ext cx="2531287" cy="1005840"/>
-          </a:xfrm>
-          <a:prstGeom prst="rect">
-            <a:avLst/>
-          </a:prstGeom>
-          <a:noFill/>
-        </p:spPr>
-        <p:txBody>
-          <a:bodyPr wrap="square" lIns="0" rIns="0" tIns="0" bIns="0" anchor="t">
-            <a:noAutofit/>
-          </a:bodyPr>
-          <a:lstStyle/>
-          <a:p>
-            <a:pPr algn="l">
-              <a:lnSpc>
-                <a:spcPct val="105000"/>
-              </a:lnSpc>
-              <a:spcBef>
-                <a:spcPts val="0"/>
-              </a:spcBef>
-              <a:spcAft>
-                <a:spcPts val="0"/>
-              </a:spcAft>
-            </a:pPr>
-            <a:r>
-              <a:rPr sz="2000" b="0" lang="en-GB">
-                <a:solidFill>
-                  <a:srgbClr val="E9EEF3"/>
-                </a:solidFill>
-                <a:latin typeface="Atkinson Hyperlegible"/>
-                <a:ea typeface="Atkinson Hyperlegible"/>
-                <a:cs typeface="Atkinson Hyperlegible"/>
-              </a:rPr>
-              <a:t>LiDAR of known, public sites</a:t>
             </a:r>
           </a:p>
         </p:txBody>

</xml_diff>

<commit_message>
Architecture diagrams (simple and detailed, draw.io) on the deck's slide 4 and a backup slide
</commit_message>
<xml_diff>
--- a/docs/demo/agentic-ai-for-earth-intro.pptx
+++ b/docs/demo/agentic-ai-for-earth-intro.pptx
@@ -10,6 +10,7 @@
     <p:sldId id="258" r:id="rId10"/>
     <p:sldId id="259" r:id="rId11"/>
     <p:sldId id="260" r:id="rId12"/>
+    <p:sldId id="261" r:id="rId13"/>
   </p:sldIdLst>
   <p:sldSz cx="12192000" cy="6858000" type="screen4x3"/>
   <p:notesSz cx="6858000" cy="9144000"/>
@@ -792,7 +793,7 @@
                 <a:ea typeface="Atkinson Hyperlegible"/>
                 <a:cs typeface="Atkinson Hyperlegible"/>
               </a:rPr>
-              <a:t>Four jobs, one platform; candidates, never accusations.</a:t>
+              <a:t>Four jobs, one platform. The agent drafts; a person decides.</a:t>
             </a:r>
           </a:p>
           <a:p>
@@ -815,7 +816,7 @@
                 <a:ea typeface="Atkinson Hyperlegible"/>
                 <a:cs typeface="Atkinson Hyperlegible"/>
               </a:rPr>
-              <a:t>First, the Earth Analyst fetches a Sentinel-2 scene, looks at it, then measures plant health or finds similar places. Second, the AI Archaeologist reads LiDAR of earthworks already on the public record, and only those. Third, the Methane Hunter follows a satellite tip to a methane site, checks ground records and drafts a brief for an analyst. Last, Dark Vessels compares a radar pass over the Galápagos with ship broadcasts, called AIS, and checks where those broadcasts can be heard. A silent target there is a candidate for a patrol, never an accusation.</a:t>
+              <a:t>First, the Earth Analyst fetches a Sentinel-2 scene, looks at it, then measures plant health or finds similar places. Second, the AI Archaeologist reads LiDAR of earthworks already on the public record, and only those. Third, the Methane Hunter follows a satellite tip to a methane site, checks ground records and drafts a brief for an analyst. Last, Dark Vessels compares a radar pass over the Galápagos with ship broadcasts, called AIS, and checks where those broadcasts can be heard. A target that isn’t broadcasting there becomes a reason for a patrol to look. The agent predicts where to look next, and the officer decides whether to send one.</a:t>
             </a:r>
           </a:p>
           <a:p>
@@ -926,7 +927,7 @@
                 <a:ea typeface="Atkinson Hyperlegible"/>
                 <a:cs typeface="Atkinson Hyperlegible"/>
               </a:rPr>
-              <a:t>One runtime per agent; a person files.</a:t>
+              <a:t>Four agents, one model; a person decides.</a:t>
             </a:r>
           </a:p>
           <a:p>
@@ -949,7 +950,7 @@
                 <a:ea typeface="Atkinson Hyperlegible"/>
                 <a:cs typeface="Atkinson Hyperlegible"/>
               </a:rPr>
-              <a:t>Each agent is its own runtime on Amazon Bedrock AgentCore. A foundation model, Claude Sonnet 4.6 by default, reads the question and calls the agent’s tools, sometimes several at once: fetch a scene, compute an index, check a record. How freely it chooses varies: the Earth Analyst picks its own tools, dates and scenes; the archaeologist works over prepared LiDAR but picks the line it measures. All four share one map stage, with session files in Amazon S3. The analyst files the brief and the officer approves the tasking; the backend enforces that, not the model.</a:t>
+              <a:t>Left to right. I ask a question on the stage, a web app on AWS Fargate behind Amazon CloudFront. It goes to one of four agents, each on its own Amazon Bedrock AgentCore runtime, all using one model, Claude Sonnet 4.6. They read satellite imagery, Clay embeddings and Esri’s maps live; the methane data, radar, ship broadcasts and LiDAR are prepared ahead and cached in S3. Nothing is filed until a person decides; then it posts to Slack. For the technical half: Strands agents, streaming each step to the stage, with session files in S3.</a:t>
             </a:r>
           </a:p>
           <a:p>
@@ -1107,6 +1108,255 @@
                 <a:cs typeface="Atkinson Hyperlegible"/>
               </a:rPr>
               <a:t>Let’s start with the Earth Analyst.</a:t>
+            </a:r>
+          </a:p>
+        </p:txBody>
+      </p:sp>
+      <p:sp>
+        <p:nvSpPr>
+          <p:cNvPr id="4" name="Slide Number Placeholder 3"/>
+          <p:cNvSpPr>
+            <a:spLocks noGrp="1"/>
+          </p:cNvSpPr>
+          <p:nvPr>
+            <p:ph type="sldNum" idx="5" sz="quarter"/>
+          </p:nvPr>
+        </p:nvSpPr>
+        <p:spPr/>
+      </p:sp>
+    </p:spTree>
+  </p:cSld>
+  <p:clrMapOvr>
+    <a:masterClrMapping/>
+  </p:clrMapOvr>
+</p:notes>
+</file>
+
+<file path=ppt/notesSlides/notesSlide6.xml><?xml version="1.0" encoding="utf-8"?>
+<p:notes xmlns:a="http://schemas.openxmlformats.org/drawingml/2006/main" xmlns:p="http://schemas.openxmlformats.org/presentationml/2006/main" xmlns:r="http://schemas.openxmlformats.org/officeDocument/2006/relationships">
+  <p:cSld>
+    <p:spTree>
+      <p:nvGrpSpPr>
+        <p:cNvPr id="1" name=""/>
+        <p:cNvGrpSpPr/>
+        <p:nvPr/>
+      </p:nvGrpSpPr>
+      <p:grpSpPr>
+        <a:xfrm>
+          <a:off x="0" y="0"/>
+          <a:ext cx="0" cy="0"/>
+          <a:chOff x="0" y="0"/>
+          <a:chExt cx="0" cy="0"/>
+        </a:xfrm>
+      </p:grpSpPr>
+      <p:sp>
+        <p:nvSpPr>
+          <p:cNvPr id="2" name="Slide Image Placeholder 1"/>
+          <p:cNvSpPr>
+            <a:spLocks noGrp="1"/>
+          </p:cNvSpPr>
+          <p:nvPr>
+            <p:ph type="sldImg" idx="2"/>
+          </p:nvPr>
+        </p:nvSpPr>
+        <p:spPr/>
+      </p:sp>
+      <p:sp>
+        <p:nvSpPr>
+          <p:cNvPr id="3" name="Notes Placeholder 2"/>
+          <p:cNvSpPr>
+            <a:spLocks noGrp="1"/>
+          </p:cNvSpPr>
+          <p:nvPr>
+            <p:ph type="body" idx="3" sz="quarter"/>
+          </p:nvPr>
+        </p:nvSpPr>
+        <p:spPr/>
+        <p:txBody>
+          <a:bodyPr/>
+          <a:lstStyle/>
+          <a:p>
+            <a:pPr>
+              <a:spcAft>
+                <a:spcPts val="800"/>
+              </a:spcAft>
+            </a:pPr>
+            <a:r>
+              <a:rPr sz="1400" b="1" lang="en-GB">
+                <a:latin typeface="Atkinson Hyperlegible"/>
+                <a:ea typeface="Atkinson Hyperlegible"/>
+                <a:cs typeface="Atkinson Hyperlegible"/>
+              </a:rPr>
+              <a:t>Point to land: </a:t>
+            </a:r>
+            <a:r>
+              <a:rPr sz="1400" b="0" lang="en-GB">
+                <a:latin typeface="Atkinson Hyperlegible"/>
+                <a:ea typeface="Atkinson Hyperlegible"/>
+                <a:cs typeface="Atkinson Hyperlegible"/>
+              </a:rPr>
+              <a:t>Backup for technical questions; every box on it comes from the code.</a:t>
+            </a:r>
+          </a:p>
+          <a:p>
+            <a:pPr>
+              <a:spcAft>
+                <a:spcPts val="800"/>
+              </a:spcAft>
+            </a:pPr>
+            <a:r>
+              <a:rPr sz="1400" b="1" lang="en-GB">
+                <a:latin typeface="Atkinson Hyperlegible"/>
+                <a:ea typeface="Atkinson Hyperlegible"/>
+                <a:cs typeface="Atkinson Hyperlegible"/>
+              </a:rPr>
+              <a:t>Say: </a:t>
+            </a:r>
+            <a:r>
+              <a:rPr sz="1400" b="0" lang="en-GB">
+                <a:latin typeface="Atkinson Hyperlegible"/>
+                <a:ea typeface="Atkinson Hyperlegible"/>
+                <a:cs typeface="Atkinson Hyperlegible"/>
+              </a:rPr>
+              <a:t>Only if someone asks how it works. Walk it left to right, as on the earlier slide, then answer from the lines below.</a:t>
+            </a:r>
+          </a:p>
+          <a:p>
+            <a:pPr>
+              <a:spcAft>
+                <a:spcPts val="800"/>
+              </a:spcAft>
+            </a:pPr>
+            <a:r>
+              <a:rPr sz="1400" b="1" lang="en-GB">
+                <a:latin typeface="Atkinson Hyperlegible"/>
+                <a:ea typeface="Atkinson Hyperlegible"/>
+                <a:cs typeface="Atkinson Hyperlegible"/>
+              </a:rPr>
+              <a:t>If asked about sign-in and traffic: </a:t>
+            </a:r>
+            <a:r>
+              <a:rPr sz="1400" b="0" lang="en-GB">
+                <a:latin typeface="Atkinson Hyperlegible"/>
+                <a:ea typeface="Atkinson Hyperlegible"/>
+                <a:cs typeface="Atkinson Hyperlegible"/>
+              </a:rPr>
+              <a:t>Amazon Cognito user pool, with users added by an admin only. The browser signs in and the backend checks the token on every API call. Requests go through CloudFront with AWS WAF, then an Application Load Balancer that only accepts CloudFront’s secret header, then one container image on ECS Fargate that serves the React stage and the Express backend.</a:t>
+            </a:r>
+          </a:p>
+          <a:p>
+            <a:pPr>
+              <a:spcAft>
+                <a:spcPts val="800"/>
+              </a:spcAft>
+            </a:pPr>
+            <a:r>
+              <a:rPr sz="1400" b="1" lang="en-GB">
+                <a:latin typeface="Atkinson Hyperlegible"/>
+                <a:ea typeface="Atkinson Hyperlegible"/>
+                <a:cs typeface="Atkinson Hyperlegible"/>
+              </a:rPr>
+              <a:t>If asked about the agents: </a:t>
+            </a:r>
+            <a:r>
+              <a:rPr sz="1400" b="0" lang="en-GB">
+                <a:latin typeface="Atkinson Hyperlegible"/>
+                <a:ea typeface="Atkinson Hyperlegible"/>
+                <a:cs typeface="Atkinson Hyperlegible"/>
+              </a:rPr>
+              <a:t>Four AgentCore runtimes, one per agent, each a Strands agent with its own tools. The backend calls InvokeAgentRuntime and streams each step back as server-sent events. The model is Claude Sonnet 4.6 on Amazon Bedrock, through the US cross-Region inference profile. Conversation history is kept in S3, not in AgentCore Memory.</a:t>
+            </a:r>
+          </a:p>
+          <a:p>
+            <a:pPr>
+              <a:spcAft>
+                <a:spcPts val="800"/>
+              </a:spcAft>
+            </a:pPr>
+            <a:r>
+              <a:rPr sz="1400" b="1" lang="en-GB">
+                <a:latin typeface="Atkinson Hyperlegible"/>
+                <a:ea typeface="Atkinson Hyperlegible"/>
+                <a:cs typeface="Atkinson Hyperlegible"/>
+              </a:rPr>
+              <a:t>If asked about data: </a:t>
+            </a:r>
+            <a:r>
+              <a:rPr sz="1400" b="0" lang="en-GB">
+                <a:latin typeface="Atkinson Hyperlegible"/>
+                <a:ea typeface="Atkinson Hyperlegible"/>
+                <a:cs typeface="Atkinson Hyperlegible"/>
+              </a:rPr>
+              <a:t>Live reads: Sentinel-2 and Sentinel-5P from AWS Open Data, Clay embeddings through a Lambda fan-out with DuckDB, Esri’s ArcGIS MCP server, NASA EMIT and FIRMS, OpenStreetMap and ESA’s Sentinel-1 plans. Prepared ahead: radar and AIS from Microsoft Planetary Computer and Global Fishing Watch, LiDAR from USGS 3DEP, the OGIM and GEM registries, and methane caches warmed the day before and on the day.</a:t>
+            </a:r>
+          </a:p>
+          <a:p>
+            <a:pPr>
+              <a:spcAft>
+                <a:spcPts val="800"/>
+              </a:spcAft>
+            </a:pPr>
+            <a:r>
+              <a:rPr sz="1400" b="1" lang="en-GB">
+                <a:latin typeface="Atkinson Hyperlegible"/>
+                <a:ea typeface="Atkinson Hyperlegible"/>
+                <a:cs typeface="Atkinson Hyperlegible"/>
+              </a:rPr>
+              <a:t>If asked about decisions: </a:t>
+            </a:r>
+            <a:r>
+              <a:rPr sz="1400" b="0" lang="en-GB">
+                <a:latin typeface="Atkinson Hyperlegible"/>
+                <a:ea typeface="Atkinson Hyperlegible"/>
+                <a:cs typeface="Atkinson Hyperlegible"/>
+              </a:rPr>
+              <a:t>Nothing is filed until the analyst or the officer clicks. The backend writes the record to S3 and posts to Slack; the brief’s Slack webhook URL comes from Secrets Manager.</a:t>
+            </a:r>
+          </a:p>
+          <a:p>
+            <a:pPr>
+              <a:spcAft>
+                <a:spcPts val="800"/>
+              </a:spcAft>
+            </a:pPr>
+            <a:r>
+              <a:rPr sz="1400" b="1" lang="en-GB">
+                <a:latin typeface="Atkinson Hyperlegible"/>
+                <a:ea typeface="Atkinson Hyperlegible"/>
+                <a:cs typeface="Atkinson Hyperlegible"/>
+              </a:rPr>
+              <a:t>If asked about tracing: </a:t>
+            </a:r>
+            <a:r>
+              <a:rPr sz="1400" b="0" lang="en-GB">
+                <a:latin typeface="Atkinson Hyperlegible"/>
+                <a:ea typeface="Atkinson Hyperlegible"/>
+                <a:cs typeface="Atkinson Hyperlegible"/>
+              </a:rPr>
+              <a:t>It isn’t on this diagram because it wasn’t confirmed for the stage runtimes, so don’t promise a trace view.</a:t>
+            </a:r>
+          </a:p>
+          <a:p>
+            <a:pPr>
+              <a:spcAft>
+                <a:spcPts val="800"/>
+              </a:spcAft>
+            </a:pPr>
+            <a:r>
+              <a:rPr sz="1400" b="1" lang="en-GB">
+                <a:latin typeface="Atkinson Hyperlegible"/>
+                <a:ea typeface="Atkinson Hyperlegible"/>
+                <a:cs typeface="Atkinson Hyperlegible"/>
+              </a:rPr>
+              <a:t>Transition: </a:t>
+            </a:r>
+            <a:r>
+              <a:rPr sz="1400" b="0" lang="en-GB">
+                <a:latin typeface="Atkinson Hyperlegible"/>
+                <a:ea typeface="Atkinson Hyperlegible"/>
+                <a:cs typeface="Atkinson Hyperlegible"/>
+              </a:rPr>
+              <a:t>Back to your questions.</a:t>
             </a:r>
           </a:p>
         </p:txBody>
@@ -5415,7 +5665,7 @@
                 <a:ea typeface="Atkinson Hyperlegible"/>
                 <a:cs typeface="Atkinson Hyperlegible"/>
               </a:rPr>
-              <a:t>Radar candidates, never accusations</a:t>
+              <a:t>Spots silent ships, plans the patrol</a:t>
             </a:r>
           </a:p>
         </p:txBody>
@@ -5499,281 +5749,42 @@
       </p:sp>
       <p:sp>
         <p:nvSpPr>
-          <p:cNvPr id="3" name="Built 1"/>
-          <p:cNvSpPr txBox="1"/>
-          <p:nvPr/>
-        </p:nvSpPr>
-        <p:spPr>
-          <a:xfrm>
-            <a:off x="1280160" y="1874519"/>
-            <a:ext cx="10180015" cy="411479"/>
-          </a:xfrm>
-          <a:prstGeom prst="rect">
-            <a:avLst/>
-          </a:prstGeom>
-          <a:noFill/>
-        </p:spPr>
-        <p:txBody>
-          <a:bodyPr wrap="square" lIns="0" rIns="0" tIns="0" bIns="0" anchor="t">
-            <a:noAutofit/>
-          </a:bodyPr>
-          <a:lstStyle/>
-          <a:p>
-            <a:pPr algn="l">
-              <a:lnSpc>
-                <a:spcPct val="100000"/>
-              </a:lnSpc>
-              <a:spcBef>
-                <a:spcPts val="0"/>
-              </a:spcBef>
-              <a:spcAft>
-                <a:spcPts val="0"/>
-              </a:spcAft>
-            </a:pPr>
-            <a:r>
-              <a:rPr sz="2400" b="0" lang="en-GB">
-                <a:solidFill>
-                  <a:srgbClr val="E9EEF3"/>
-                </a:solidFill>
-                <a:latin typeface="Atkinson Hyperlegible"/>
-                <a:ea typeface="Atkinson Hyperlegible"/>
-                <a:cs typeface="Atkinson Hyperlegible"/>
-              </a:rPr>
-              <a:t>One AgentCore runtime per agent</a:t>
-            </a:r>
-          </a:p>
-        </p:txBody>
-      </p:sp>
-      <p:sp>
-        <p:nvSpPr>
-          <p:cNvPr id="4" name="Built 2"/>
-          <p:cNvSpPr txBox="1"/>
-          <p:nvPr/>
-        </p:nvSpPr>
-        <p:spPr>
-          <a:xfrm>
-            <a:off x="1280160" y="2752344"/>
-            <a:ext cx="10180015" cy="411479"/>
-          </a:xfrm>
-          <a:prstGeom prst="rect">
-            <a:avLst/>
-          </a:prstGeom>
-          <a:noFill/>
-        </p:spPr>
-        <p:txBody>
-          <a:bodyPr wrap="square" lIns="0" rIns="0" tIns="0" bIns="0" anchor="t">
-            <a:noAutofit/>
-          </a:bodyPr>
-          <a:lstStyle/>
-          <a:p>
-            <a:pPr algn="l">
-              <a:lnSpc>
-                <a:spcPct val="100000"/>
-              </a:lnSpc>
-              <a:spcBef>
-                <a:spcPts val="0"/>
-              </a:spcBef>
-              <a:spcAft>
-                <a:spcPts val="0"/>
-              </a:spcAft>
-            </a:pPr>
-            <a:r>
-              <a:rPr sz="2400" b="0" lang="en-GB">
-                <a:solidFill>
-                  <a:srgbClr val="E9EEF3"/>
-                </a:solidFill>
-                <a:latin typeface="Atkinson Hyperlegible"/>
-                <a:ea typeface="Atkinson Hyperlegible"/>
-                <a:cs typeface="Atkinson Hyperlegible"/>
-              </a:rPr>
-              <a:t>A foundation model calls tools</a:t>
-            </a:r>
-          </a:p>
-        </p:txBody>
-      </p:sp>
-      <p:sp>
-        <p:nvSpPr>
-          <p:cNvPr id="5" name="Built 3"/>
-          <p:cNvSpPr txBox="1"/>
-          <p:nvPr/>
-        </p:nvSpPr>
-        <p:spPr>
-          <a:xfrm>
-            <a:off x="1280160" y="3630168"/>
-            <a:ext cx="10180015" cy="411479"/>
-          </a:xfrm>
-          <a:prstGeom prst="rect">
-            <a:avLst/>
-          </a:prstGeom>
-          <a:noFill/>
-        </p:spPr>
-        <p:txBody>
-          <a:bodyPr wrap="square" lIns="0" rIns="0" tIns="0" bIns="0" anchor="t">
-            <a:noAutofit/>
-          </a:bodyPr>
-          <a:lstStyle/>
-          <a:p>
-            <a:pPr algn="l">
-              <a:lnSpc>
-                <a:spcPct val="100000"/>
-              </a:lnSpc>
-              <a:spcBef>
-                <a:spcPts val="0"/>
-              </a:spcBef>
-              <a:spcAft>
-                <a:spcPts val="0"/>
-              </a:spcAft>
-            </a:pPr>
-            <a:r>
-              <a:rPr sz="2400" b="0" lang="en-GB">
-                <a:solidFill>
-                  <a:srgbClr val="E9EEF3"/>
-                </a:solidFill>
-                <a:latin typeface="Atkinson Hyperlegible"/>
-                <a:ea typeface="Atkinson Hyperlegible"/>
-                <a:cs typeface="Atkinson Hyperlegible"/>
-              </a:rPr>
-              <a:t>Sentinel-2, methane sensors, radar and AIS, LiDAR</a:t>
-            </a:r>
-          </a:p>
-        </p:txBody>
-      </p:sp>
-      <p:sp>
-        <p:nvSpPr>
-          <p:cNvPr id="6" name="Built 4"/>
-          <p:cNvSpPr txBox="1"/>
-          <p:nvPr/>
-        </p:nvSpPr>
-        <p:spPr>
-          <a:xfrm>
-            <a:off x="1280160" y="4507992"/>
-            <a:ext cx="10180015" cy="411479"/>
-          </a:xfrm>
-          <a:prstGeom prst="rect">
-            <a:avLst/>
-          </a:prstGeom>
-          <a:noFill/>
-        </p:spPr>
-        <p:txBody>
-          <a:bodyPr wrap="square" lIns="0" rIns="0" tIns="0" bIns="0" anchor="t">
-            <a:noAutofit/>
-          </a:bodyPr>
-          <a:lstStyle/>
-          <a:p>
-            <a:pPr algn="l">
-              <a:lnSpc>
-                <a:spcPct val="100000"/>
-              </a:lnSpc>
-              <a:spcBef>
-                <a:spcPts val="0"/>
-              </a:spcBef>
-              <a:spcAft>
-                <a:spcPts val="0"/>
-              </a:spcAft>
-            </a:pPr>
-            <a:r>
-              <a:rPr sz="2400" b="0" lang="en-GB">
-                <a:solidFill>
-                  <a:srgbClr val="E9EEF3"/>
-                </a:solidFill>
-                <a:latin typeface="Atkinson Hyperlegible"/>
-                <a:ea typeface="Atkinson Hyperlegible"/>
-                <a:cs typeface="Atkinson Hyperlegible"/>
-              </a:rPr>
-              <a:t>Shared map stage, session files in S3</a:t>
-            </a:r>
-          </a:p>
-        </p:txBody>
-      </p:sp>
-      <p:sp>
-        <p:nvSpPr>
-          <p:cNvPr id="7" name="Built 5"/>
-          <p:cNvSpPr txBox="1"/>
-          <p:nvPr/>
-        </p:nvSpPr>
-        <p:spPr>
-          <a:xfrm>
-            <a:off x="1280160" y="5385816"/>
-            <a:ext cx="10180015" cy="411479"/>
-          </a:xfrm>
-          <a:prstGeom prst="rect">
-            <a:avLst/>
-          </a:prstGeom>
-          <a:noFill/>
-        </p:spPr>
-        <p:txBody>
-          <a:bodyPr wrap="square" lIns="0" rIns="0" tIns="0" bIns="0" anchor="t">
-            <a:noAutofit/>
-          </a:bodyPr>
-          <a:lstStyle/>
-          <a:p>
-            <a:pPr algn="l">
-              <a:lnSpc>
-                <a:spcPct val="100000"/>
-              </a:lnSpc>
-              <a:spcBef>
-                <a:spcPts val="0"/>
-              </a:spcBef>
-              <a:spcAft>
-                <a:spcPts val="0"/>
-              </a:spcAft>
-            </a:pPr>
-            <a:r>
-              <a:rPr sz="2400" b="0" lang="en-GB">
-                <a:solidFill>
-                  <a:srgbClr val="E9EEF3"/>
-                </a:solidFill>
-                <a:latin typeface="Atkinson Hyperlegible"/>
-                <a:ea typeface="Atkinson Hyperlegible"/>
-                <a:cs typeface="Atkinson Hyperlegible"/>
-              </a:rPr>
-              <a:t>Analyst files the brief, officer approves the tasking</a:t>
-            </a:r>
-          </a:p>
-        </p:txBody>
-      </p:sp>
-      <p:cxnSp>
-        <p:nvCxnSpPr>
-          <p:cNvPr id="8" name="Built rail"/>
-          <p:cNvCxnSpPr/>
-          <p:nvPr/>
-        </p:nvCxnSpPr>
-        <p:spPr>
-          <a:xfrm>
-            <a:off x="841248" y="2087880"/>
-            <a:ext cx="0" cy="3511296"/>
-          </a:xfrm>
-          <a:prstGeom prst="line">
-            <a:avLst/>
-          </a:prstGeom>
-          <a:ln w="19050">
-            <a:solidFill>
-              <a:srgbClr val="43484F"/>
-            </a:solidFill>
-          </a:ln>
-        </p:spPr>
-      </p:cxnSp>
-      <p:sp>
-        <p:nvSpPr>
-          <p:cNvPr id="9" name="Built dot 1"/>
+          <p:cNvPr id="3" name="Diagram panel"/>
           <p:cNvSpPr/>
           <p:nvPr/>
         </p:nvSpPr>
         <p:spPr>
           <a:xfrm>
-            <a:off x="749808" y="1996439"/>
-            <a:ext cx="182880" cy="182880"/>
-          </a:xfrm>
-          <a:prstGeom prst="ellipse">
-            <a:avLst/>
+            <a:off x="731520" y="1417320"/>
+            <a:ext cx="10725912" cy="4875480"/>
+          </a:xfrm>
+          <a:prstGeom prst="roundRect">
+            <a:avLst>
+              <a:gd name="adj" fmla="val 2250"/>
+            </a:avLst>
           </a:prstGeom>
           <a:solidFill>
-            <a:srgbClr val="8FA3B8"/>
+            <a:srgbClr val="FFFFFF"/>
           </a:solidFill>
           <a:ln>
             <a:noFill/>
           </a:ln>
-        </p:spPr>
+          <a:effectLst/>
+        </p:spPr>
+        <p:style>
+          <a:lnRef idx="1">
+            <a:schemeClr val="accent1"/>
+          </a:lnRef>
+          <a:fillRef idx="3">
+            <a:schemeClr val="accent1"/>
+          </a:fillRef>
+          <a:effectRef idx="2">
+            <a:schemeClr val="accent1"/>
+          </a:effectRef>
+          <a:fontRef idx="minor">
+            <a:schemeClr val="lt1"/>
+          </a:fontRef>
+        </p:style>
         <p:txBody>
           <a:bodyPr rtlCol="0" anchor="ctr"/>
           <a:lstStyle/>
@@ -5782,122 +5793,30 @@
           </a:p>
         </p:txBody>
       </p:sp>
-      <p:sp>
-        <p:nvSpPr>
-          <p:cNvPr id="10" name="Built dot 2"/>
-          <p:cNvSpPr/>
+      <p:pic>
+        <p:nvPicPr>
+          <p:cNvPr id="4" name="Architecture diagram" descr="Architecture, left to right. The presenter asks through Amazon CloudFront to the web app on AWS Fargate. Four agents, Earth Analyst, AI Archaeologist, Methane Hunter and Dark Vessels, one AgentCore runtime each, sit around one model, Claude Sonnet 4.6, on Amazon Bedrock. Data sources: read live, satellite imagery, Clay embeddings and Esri ArcGIS MCP; prepared ahead and cached in S3, methane sensors, radar and AIS, and LiDAR terrain. A person decides, then the app files the decision and posts it to Slack."/>
+          <p:cNvPicPr>
+            <a:picLocks noChangeAspect="1"/>
+          </p:cNvPicPr>
           <p:nvPr/>
-        </p:nvSpPr>
-        <p:spPr>
-          <a:xfrm>
-            <a:off x="749808" y="2874264"/>
-            <a:ext cx="182880" cy="182880"/>
-          </a:xfrm>
-          <a:prstGeom prst="ellipse">
+        </p:nvPicPr>
+        <p:blipFill>
+          <a:blip r:embed="rId3"/>
+          <a:stretch>
+            <a:fillRect/>
+          </a:stretch>
+        </p:blipFill>
+        <p:spPr>
+          <a:xfrm>
+            <a:off x="786384" y="1472184"/>
+            <a:ext cx="10616184" cy="4765753"/>
+          </a:xfrm>
+          <a:prstGeom prst="rect">
             <a:avLst/>
           </a:prstGeom>
-          <a:solidFill>
-            <a:srgbClr val="8FA3B8"/>
-          </a:solidFill>
-          <a:ln>
-            <a:noFill/>
-          </a:ln>
-        </p:spPr>
-        <p:txBody>
-          <a:bodyPr rtlCol="0" anchor="ctr"/>
-          <a:lstStyle/>
-          <a:p>
-            <a:pPr algn="ctr"/>
-          </a:p>
-        </p:txBody>
-      </p:sp>
-      <p:sp>
-        <p:nvSpPr>
-          <p:cNvPr id="11" name="Built dot 3"/>
-          <p:cNvSpPr/>
-          <p:nvPr/>
-        </p:nvSpPr>
-        <p:spPr>
-          <a:xfrm>
-            <a:off x="749808" y="3752088"/>
-            <a:ext cx="182880" cy="182880"/>
-          </a:xfrm>
-          <a:prstGeom prst="ellipse">
-            <a:avLst/>
-          </a:prstGeom>
-          <a:solidFill>
-            <a:srgbClr val="8FA3B8"/>
-          </a:solidFill>
-          <a:ln>
-            <a:noFill/>
-          </a:ln>
-        </p:spPr>
-        <p:txBody>
-          <a:bodyPr rtlCol="0" anchor="ctr"/>
-          <a:lstStyle/>
-          <a:p>
-            <a:pPr algn="ctr"/>
-          </a:p>
-        </p:txBody>
-      </p:sp>
-      <p:sp>
-        <p:nvSpPr>
-          <p:cNvPr id="12" name="Built dot 4"/>
-          <p:cNvSpPr/>
-          <p:nvPr/>
-        </p:nvSpPr>
-        <p:spPr>
-          <a:xfrm>
-            <a:off x="749808" y="4629912"/>
-            <a:ext cx="182880" cy="182880"/>
-          </a:xfrm>
-          <a:prstGeom prst="ellipse">
-            <a:avLst/>
-          </a:prstGeom>
-          <a:solidFill>
-            <a:srgbClr val="8FA3B8"/>
-          </a:solidFill>
-          <a:ln>
-            <a:noFill/>
-          </a:ln>
-        </p:spPr>
-        <p:txBody>
-          <a:bodyPr rtlCol="0" anchor="ctr"/>
-          <a:lstStyle/>
-          <a:p>
-            <a:pPr algn="ctr"/>
-          </a:p>
-        </p:txBody>
-      </p:sp>
-      <p:sp>
-        <p:nvSpPr>
-          <p:cNvPr id="13" name="Built dot 5"/>
-          <p:cNvSpPr/>
-          <p:nvPr/>
-        </p:nvSpPr>
-        <p:spPr>
-          <a:xfrm>
-            <a:off x="731520" y="5489448"/>
-            <a:ext cx="219456" cy="219456"/>
-          </a:xfrm>
-          <a:prstGeom prst="ellipse">
-            <a:avLst/>
-          </a:prstGeom>
-          <a:solidFill>
-            <a:srgbClr val="F5A524"/>
-          </a:solidFill>
-          <a:ln>
-            <a:noFill/>
-          </a:ln>
-        </p:spPr>
-        <p:txBody>
-          <a:bodyPr rtlCol="0" anchor="ctr"/>
-          <a:lstStyle/>
-          <a:p>
-            <a:pPr algn="ctr"/>
-          </a:p>
-        </p:txBody>
-      </p:sp>
+        </p:spPr>
+      </p:pic>
     </p:spTree>
   </p:cSld>
   <p:clrMapOvr>
@@ -6973,6 +6892,153 @@
           </a:p>
         </p:txBody>
       </p:sp>
+    </p:spTree>
+  </p:cSld>
+  <p:clrMapOvr>
+    <a:masterClrMapping/>
+  </p:clrMapOvr>
+</p:sld>
+</file>
+
+<file path=ppt/slides/slide6.xml><?xml version="1.0" encoding="utf-8"?>
+<p:sld xmlns:a="http://schemas.openxmlformats.org/drawingml/2006/main" xmlns:p="http://schemas.openxmlformats.org/presentationml/2006/main" xmlns:r="http://schemas.openxmlformats.org/officeDocument/2006/relationships">
+  <p:cSld>
+    <p:bg>
+      <p:bgPr>
+        <a:solidFill>
+          <a:srgbClr val="0F141B"/>
+        </a:solidFill>
+        <a:effectLst/>
+      </p:bgPr>
+    </p:bg>
+    <p:spTree>
+      <p:nvGrpSpPr>
+        <p:cNvPr id="1" name=""/>
+        <p:cNvGrpSpPr/>
+        <p:nvPr/>
+      </p:nvGrpSpPr>
+      <p:grpSpPr/>
+      <p:sp>
+        <p:nvSpPr>
+          <p:cNvPr id="2" name="Title"/>
+          <p:cNvSpPr>
+            <a:spLocks noGrp="1"/>
+          </p:cNvSpPr>
+          <p:nvPr>
+            <p:ph type="title"/>
+          </p:nvPr>
+        </p:nvSpPr>
+        <p:spPr>
+          <a:xfrm>
+            <a:off x="457200" y="347472"/>
+            <a:ext cx="11274552" cy="548640"/>
+          </a:xfrm>
+          <a:prstGeom prst="rect">
+            <a:avLst/>
+          </a:prstGeom>
+          <a:noFill/>
+        </p:spPr>
+        <p:txBody>
+          <a:bodyPr wrap="square" lIns="0" rIns="0" tIns="0" bIns="0" anchor="t">
+            <a:noAutofit/>
+          </a:bodyPr>
+          <a:lstStyle/>
+          <a:p>
+            <a:pPr algn="l">
+              <a:lnSpc>
+                <a:spcPct val="100000"/>
+              </a:lnSpc>
+              <a:spcBef>
+                <a:spcPts val="0"/>
+              </a:spcBef>
+              <a:spcAft>
+                <a:spcPts val="0"/>
+              </a:spcAft>
+            </a:pPr>
+            <a:r>
+              <a:rPr sz="3200" b="1" lang="en-GB">
+                <a:solidFill>
+                  <a:srgbClr val="E9EEF3"/>
+                </a:solidFill>
+                <a:latin typeface="Atkinson Hyperlegible"/>
+                <a:ea typeface="Atkinson Hyperlegible"/>
+                <a:cs typeface="Atkinson Hyperlegible"/>
+              </a:rPr>
+              <a:t>Backup: the architecture in detail</a:t>
+            </a:r>
+          </a:p>
+        </p:txBody>
+      </p:sp>
+      <p:sp>
+        <p:nvSpPr>
+          <p:cNvPr id="3" name="Diagram panel"/>
+          <p:cNvSpPr/>
+          <p:nvPr/>
+        </p:nvSpPr>
+        <p:spPr>
+          <a:xfrm>
+            <a:off x="457200" y="1005840"/>
+            <a:ext cx="11274552" cy="5410405"/>
+          </a:xfrm>
+          <a:prstGeom prst="roundRect">
+            <a:avLst>
+              <a:gd name="adj" fmla="val 2028"/>
+            </a:avLst>
+          </a:prstGeom>
+          <a:solidFill>
+            <a:srgbClr val="FFFFFF"/>
+          </a:solidFill>
+          <a:ln>
+            <a:noFill/>
+          </a:ln>
+          <a:effectLst/>
+        </p:spPr>
+        <p:style>
+          <a:lnRef idx="1">
+            <a:schemeClr val="accent1"/>
+          </a:lnRef>
+          <a:fillRef idx="3">
+            <a:schemeClr val="accent1"/>
+          </a:fillRef>
+          <a:effectRef idx="2">
+            <a:schemeClr val="accent1"/>
+          </a:effectRef>
+          <a:fontRef idx="minor">
+            <a:schemeClr val="lt1"/>
+          </a:fontRef>
+        </p:style>
+        <p:txBody>
+          <a:bodyPr rtlCol="0" anchor="ctr"/>
+          <a:lstStyle/>
+          <a:p>
+            <a:pPr algn="ctr"/>
+          </a:p>
+        </p:txBody>
+      </p:sp>
+      <p:pic>
+        <p:nvPicPr>
+          <p:cNvPr id="4" name="Detailed architecture diagram" descr="Detailed architecture. Tile server: API Gateway and TiTiler on Lambda. Stage: Amazon Cognito, AWS WAF on CloudFront, Application Load Balancer, Amazon ECS on Fargate with the React stage and the Express backend, AWS Secrets Manager. Agents: one AgentCore runtime per agent with its main tools, Claude Sonnet 4.6 on Amazon Bedrock, a Lambda for the Clay embeddings. The S3 project bucket holds sessions and filed decisions. Data layer: AWS Open Data, live external APIs, and our S3 caches prepared ahead by build scripts. Filed decisions post to Slack."/>
+          <p:cNvPicPr>
+            <a:picLocks noChangeAspect="1"/>
+          </p:cNvPicPr>
+          <p:nvPr/>
+        </p:nvPicPr>
+        <p:blipFill>
+          <a:blip r:embed="rId2"/>
+          <a:stretch>
+            <a:fillRect/>
+          </a:stretch>
+        </p:blipFill>
+        <p:spPr>
+          <a:xfrm>
+            <a:off x="512064" y="1060704"/>
+            <a:ext cx="11164824" cy="5300677"/>
+          </a:xfrm>
+          <a:prstGeom prst="rect">
+            <a:avLst/>
+          </a:prstGeom>
+        </p:spPr>
+      </p:pic>
     </p:spTree>
   </p:cSld>
   <p:clrMapOvr>

</xml_diff>

<commit_message>
Deck slide 6 notes: methane data warmed ahead (matches slide 4); web app logs to CloudWatch
</commit_message>
<xml_diff>
--- a/docs/demo/agentic-ai-for-earth-intro.pptx
+++ b/docs/demo/agentic-ai-for-earth-intro.pptx
@@ -1287,7 +1287,7 @@
                 <a:ea typeface="Atkinson Hyperlegible"/>
                 <a:cs typeface="Atkinson Hyperlegible"/>
               </a:rPr>
-              <a:t>Live reads: Sentinel-2 and Sentinel-5P from AWS Open Data, Clay embeddings through a Lambda fan-out with DuckDB, Esri’s ArcGIS MCP server, NASA EMIT and FIRMS, OpenStreetMap and ESA’s Sentinel-1 plans. Prepared ahead: radar and AIS from Microsoft Planetary Computer and Global Fishing Watch, LiDAR from USGS 3DEP, the OGIM and GEM registries, and methane caches warmed the day before and on the day.</a:t>
+              <a:t>Live reads: Sentinel-2 from AWS Open Data, Clay embeddings through a Lambda fan-out with DuckDB, Esri’s ArcGIS MCP server, OpenStreetMap and ESA’s Sentinel-1 plans. The methane data, Sentinel-5P from AWS Open Data with NASA EMIT and FIRMS, is warmed the day before and on the day, and fetched live only if something is missing. Prepared ahead: radar and AIS from Microsoft Planetary Computer and Global Fishing Watch, LiDAR from USGS 3DEP, and the OGIM and GEM registries.</a:t>
             </a:r>
           </a:p>
           <a:p>
@@ -1333,7 +1333,7 @@
                 <a:ea typeface="Atkinson Hyperlegible"/>
                 <a:cs typeface="Atkinson Hyperlegible"/>
               </a:rPr>
-              <a:t>It isn’t on this diagram because it wasn’t confirmed for the stage runtimes, so don’t promise a trace view.</a:t>
+              <a:t>The web app’s logs and Container Insights go to Amazon CloudWatch. Agent traces aren’t on this diagram because they weren’t confirmed for the stage runtimes, so don’t promise a trace view.</a:t>
             </a:r>
           </a:p>
           <a:p>

</xml_diff>

<commit_message>
Deck notes: slide 2 states the problem without previewing the acts; slide 3 point to land shortened
</commit_message>
<xml_diff>
--- a/docs/demo/agentic-ai-for-earth-intro.pptx
+++ b/docs/demo/agentic-ai-for-earth-intro.pptx
@@ -659,7 +659,7 @@
                 <a:ea typeface="Atkinson Hyperlegible"/>
                 <a:cs typeface="Atkinson Hyperlegible"/>
               </a:rPr>
-              <a:t>The agent does the legwork; a person makes the call.</a:t>
+              <a:t>There is more Earth data than people can read, so the agent reads and a person decides.</a:t>
             </a:r>
           </a:p>
           <a:p>
@@ -682,7 +682,7 @@
                 <a:ea typeface="Atkinson Hyperlegible"/>
                 <a:cs typeface="Atkinson Hyperlegible"/>
               </a:rPr>
-              <a:t>Here’s the problem. We collect more Earth observation data than people can read. In the first act, one question compares about 190,000 patches of New York State. In the methane act, the agent scans nine watch areas with one sensor in orbit, then checks the strongest with a sharper one. In the last act, around a hundred vessels an hour broadcast inside one marine reserve. Nobody reads all that by hand. So the agent does the reading and the legwork, and shows its evidence. A person makes the call.</a:t>
+              <a:t>Here’s the problem. Satellites photograph the whole planet again every few days, from dozens of missions, and most of it is never looked at closely by a person. The bottleneck isn’t the data, it’s people’s time to read it. So we hand the reading and the legwork to an agent: it finds the right data, looks at it, measures, and shows its evidence. A person makes the call.</a:t>
             </a:r>
           </a:p>
           <a:p>
@@ -705,7 +705,7 @@
                 <a:ea typeface="Atkinson Hyperlegible"/>
                 <a:cs typeface="Atkinson Hyperlegible"/>
               </a:rPr>
-              <a:t>Here are the four places we’ll go.</a:t>
+              <a:t>Here are the four places we’ll see that.</a:t>
             </a:r>
           </a:p>
         </p:txBody>
@@ -793,7 +793,7 @@
                 <a:ea typeface="Atkinson Hyperlegible"/>
                 <a:cs typeface="Atkinson Hyperlegible"/>
               </a:rPr>
-              <a:t>Four jobs, one platform. The agent drafts; a person decides.</a:t>
+              <a:t>Four different jobs, one platform.</a:t>
             </a:r>
           </a:p>
           <a:p>

</xml_diff>

<commit_message>
Architecture diagrams: analyst or officer as the user and the decider, all data sources listed, Web app, model outside the agent group
</commit_message>
<xml_diff>
--- a/docs/demo/agentic-ai-for-earth-intro.pptx
+++ b/docs/demo/agentic-ai-for-earth-intro.pptx
@@ -927,7 +927,7 @@
                 <a:ea typeface="Atkinson Hyperlegible"/>
                 <a:cs typeface="Atkinson Hyperlegible"/>
               </a:rPr>
-              <a:t>Four agents, one model; a person decides.</a:t>
+              <a:t>Four agents share one model; the analyst or officer decides.</a:t>
             </a:r>
           </a:p>
           <a:p>
@@ -950,7 +950,7 @@
                 <a:ea typeface="Atkinson Hyperlegible"/>
                 <a:cs typeface="Atkinson Hyperlegible"/>
               </a:rPr>
-              <a:t>Left to right. I ask a question on the stage, a web app on AWS Fargate behind Amazon CloudFront. It goes to one of four agents, each on its own Amazon Bedrock AgentCore runtime, all using one model, Claude Sonnet 4.6. They read satellite imagery, Clay embeddings and Esri’s maps live; the methane data, radar, ship broadcasts and LiDAR are prepared ahead and cached in S3. Nothing is filed until a person decides; then it posts to Slack. For the technical half: Strands agents, streaming each step to the stage, with session files in S3.</a:t>
+              <a:t>Left to right. The analyst or officer asks in the web app, a React frontend and API backend on AWS Fargate behind Amazon CloudFront. It goes to one of four Strands agents, each on its own AgentCore runtime. Claude Sonnet 4.6 on Amazon Bedrock is the model the agents use. Along the bottom, the data sources: Sentinel-2 imagery, Sentinel-5P methane, Overture Maps and Clay embeddings from AWS Open Data; NASA’s EMIT plumes and FIRMS fires; Esri’s ArcGIS MCP server, OpenStreetMap, ESA’s Sentinel-1 plans, Sentinel-1 radar from Microsoft Planetary Computer, Global Fishing Watch, USGS LiDAR, the OGIM and GEM registries, and our own S3 bucket. Nothing is filed until the analyst or officer approves; then it goes to S3 and Slack.</a:t>
             </a:r>
           </a:p>
           <a:p>
@@ -1241,7 +1241,7 @@
                 <a:ea typeface="Atkinson Hyperlegible"/>
                 <a:cs typeface="Atkinson Hyperlegible"/>
               </a:rPr>
-              <a:t>Amazon Cognito user pool, with users added by an admin only. The browser signs in and the backend checks the token on every API call. Requests go through CloudFront with AWS WAF, then an Application Load Balancer that only accepts CloudFront’s secret header, then one container image on ECS Fargate that serves the React stage and the Express backend.</a:t>
+              <a:t>Amazon Cognito user pool, with users added by an admin only. The browser signs in and the backend checks the token on every API call. Requests go through CloudFront with AWS WAF, then an Application Load Balancer that only accepts CloudFront’s secret header, then one container image on ECS Fargate that serves the React frontend and the Express API backend.</a:t>
             </a:r>
           </a:p>
           <a:p>
@@ -1264,7 +1264,7 @@
                 <a:ea typeface="Atkinson Hyperlegible"/>
                 <a:cs typeface="Atkinson Hyperlegible"/>
               </a:rPr>
-              <a:t>Four AgentCore runtimes, one per agent, each a Strands agent with its own tools. The backend calls InvokeAgentRuntime and streams each step back as server-sent events. The model is Claude Sonnet 4.6 on Amazon Bedrock, through the US cross-Region inference profile. Conversation history is kept in S3, not in AgentCore Memory.</a:t>
+              <a:t>Four AgentCore runtimes, one per agent, each a Strands agent with its own tools. The backend calls InvokeAgentRuntime and streams each step back as server-sent events. All four call one model, Claude Sonnet 4.6 on Amazon Bedrock, through the US cross-Region inference profile; that is why it sits in its own box. Conversation history is kept in S3, not in AgentCore Memory.</a:t>
             </a:r>
           </a:p>
           <a:p>
@@ -1287,7 +1287,7 @@
                 <a:ea typeface="Atkinson Hyperlegible"/>
                 <a:cs typeface="Atkinson Hyperlegible"/>
               </a:rPr>
-              <a:t>Live reads: Sentinel-2 from AWS Open Data, Clay embeddings through a Lambda fan-out with DuckDB, Esri’s ArcGIS MCP server, OpenStreetMap and ESA’s Sentinel-1 plans. The methane data, Sentinel-5P from AWS Open Data with NASA EMIT and FIRMS, is warmed the day before and on the day, and fetched live only if something is missing. Prepared ahead: radar and AIS from Microsoft Planetary Computer and Global Fishing Watch, LiDAR from USGS 3DEP, and the OGIM and GEM registries.</a:t>
+              <a:t>The agents read Sentinel-2 from AWS Open Data, the Clay embeddings through a Lambda fan-out with DuckDB, Esri’s ArcGIS MCP server, OpenStreetMap and ESA’s Sentinel-1 plans when asked. The methane data, Sentinel-5P from AWS Open Data with NASA EMIT and FIRMS, is warmed into S3 the day before and on the day, and fetched only if something is missing. The radar and AIS from Microsoft Planetary Computer and Global Fishing Watch, the USGS 3DEP LiDAR and the OGIM and GEM registries are built into S3 by scripts before the show, so the agents never call those providers during it.</a:t>
             </a:r>
           </a:p>
           <a:p>
@@ -1333,7 +1333,7 @@
                 <a:ea typeface="Atkinson Hyperlegible"/>
                 <a:cs typeface="Atkinson Hyperlegible"/>
               </a:rPr>
-              <a:t>The web app’s logs and Container Insights go to Amazon CloudWatch. Agent traces aren’t on this diagram because they weren’t confirmed for the stage runtimes, so don’t promise a trace view.</a:t>
+              <a:t>The web app’s logs and Container Insights go to Amazon CloudWatch. Agent traces aren’t on this diagram because they weren’t confirmed for the deployed runtimes, so don’t promise a trace view.</a:t>
             </a:r>
           </a:p>
           <a:p>
@@ -5755,12 +5755,12 @@
         </p:nvSpPr>
         <p:spPr>
           <a:xfrm>
-            <a:off x="731520" y="1417320"/>
-            <a:ext cx="10725912" cy="4875480"/>
+            <a:off x="280415" y="1371600"/>
+            <a:ext cx="11631167" cy="5140105"/>
           </a:xfrm>
           <a:prstGeom prst="roundRect">
             <a:avLst>
-              <a:gd name="adj" fmla="val 2250"/>
+              <a:gd name="adj" fmla="val 2134"/>
             </a:avLst>
           </a:prstGeom>
           <a:solidFill>
@@ -5795,22 +5795,22 @@
       </p:sp>
       <p:pic>
         <p:nvPicPr>
-          <p:cNvPr id="4" name="Architecture diagram" descr="Architecture, left to right. The presenter asks through Amazon CloudFront to the web app on AWS Fargate. Four agents, Earth Analyst, AI Archaeologist, Methane Hunter and Dark Vessels, one AgentCore runtime each, sit around one model, Claude Sonnet 4.6, on Amazon Bedrock. Data sources: read live, satellite imagery, Clay embeddings and Esri ArcGIS MCP; prepared ahead and cached in S3, methane sensors, radar and AIS, and LiDAR terrain. A person decides, then the app files the decision and posts it to Slack."/>
+          <p:cNvPr id="4" name="Architecture diagram" descr="Architecture, left to right. The analyst or officer asks and approves in the web app: Amazon CloudFront in front of a React frontend and API backend on AWS Fargate. The web app invokes four agents in one Amazon Bedrock AgentCore group, one runtime each: Earth Analyst, AI Archaeologist, Methane Hunter and Dark Vessels. The agents make model calls to Claude Sonnet 4.6, in its own Amazon Bedrock box. The agents read the data sources: Amazon S3 sessions and caches; NASA EMIT methane plumes and FIRMS active fires; AWS Open Data Sentinel-2 imagery, Sentinel-5P methane, Overture Maps and Clay v1.5 embeddings via a Lambda fan-out; and other providers: Esri ArcGIS MCP server, OpenStreetMap, ESA Sentinel-1 plans, Global Fishing Watch, USGS 3DEP LiDAR, OGIM and GEM registries, and Sentinel-1 radar via Microsoft Planetary Computer. On approval the web app files to Amazon S3 and posts to Slack."/>
           <p:cNvPicPr>
             <a:picLocks noChangeAspect="1"/>
           </p:cNvPicPr>
           <p:nvPr/>
         </p:nvPicPr>
         <p:blipFill>
-          <a:blip r:embed="rId3"/>
+          <a:blip r:embed="rId4"/>
           <a:stretch>
             <a:fillRect/>
           </a:stretch>
         </p:blipFill>
         <p:spPr>
           <a:xfrm>
-            <a:off x="786384" y="1472184"/>
-            <a:ext cx="10616184" cy="4765753"/>
+            <a:off x="335279" y="1426464"/>
+            <a:ext cx="11521440" cy="5030377"/>
           </a:xfrm>
           <a:prstGeom prst="rect">
             <a:avLst/>
@@ -6977,12 +6977,12 @@
         </p:nvSpPr>
         <p:spPr>
           <a:xfrm>
-            <a:off x="457200" y="1005840"/>
-            <a:ext cx="11274552" cy="5410405"/>
+            <a:off x="457200" y="1005839"/>
+            <a:ext cx="11274552" cy="5261236"/>
           </a:xfrm>
           <a:prstGeom prst="roundRect">
             <a:avLst>
-              <a:gd name="adj" fmla="val 2028"/>
+              <a:gd name="adj" fmla="val 2085"/>
             </a:avLst>
           </a:prstGeom>
           <a:solidFill>
@@ -7017,14 +7017,14 @@
       </p:sp>
       <p:pic>
         <p:nvPicPr>
-          <p:cNvPr id="4" name="Detailed architecture diagram" descr="Detailed architecture. Tile server: API Gateway and TiTiler on Lambda. Stage: Amazon Cognito, AWS WAF on CloudFront, Application Load Balancer, Amazon ECS on Fargate with the React stage and the Express backend, AWS Secrets Manager. Agents: one AgentCore runtime per agent with its main tools, Claude Sonnet 4.6 on Amazon Bedrock, a Lambda for the Clay embeddings. The S3 project bucket holds sessions and filed decisions. Data layer: AWS Open Data, live external APIs, and our S3 caches prepared ahead by build scripts. Filed decisions post to Slack."/>
+          <p:cNvPr id="4" name="Detailed architecture diagram" descr="Detailed architecture. The analyst or officer signs in with Amazon Cognito, loads map tiles from the tile server (Amazon API Gateway and TiTiler on AWS Lambda), and asks and approves through the web app: CloudFront with AWS WAF, an Application Load Balancer, and Amazon ECS on AWS Fargate serving the React frontend and the Express API backend, with the Slack webhook URL from AWS Secrets Manager. The web app invokes four runtimes in the Amazon Bedrock AgentCore group, each a Strands agent with its main tools; they make model calls to Claude Sonnet 4.6 in its own Amazon Bedrock box. The S3 project bucket holds session files and filed briefs and taskings. Data sources by provider: AWS Open Data (Sentinel-2, Sentinel-5P, Overture Maps, Clay embeddings through a Lambda fan-out), NASA (EMIT, FIRMS), other providers (Esri ArcGIS MCP server, OpenStreetMap, ESA Sentinel-1 plans, Sentinel-1 radar from Microsoft Planetary Computer, Global Fishing Watch, USGS 3DEP LiDAR, OGIM and GEM), and Amazon S3 caches written by build scripts. Filed decisions post to Slack."/>
           <p:cNvPicPr>
             <a:picLocks noChangeAspect="1"/>
           </p:cNvPicPr>
           <p:nvPr/>
         </p:nvPicPr>
         <p:blipFill>
-          <a:blip r:embed="rId2"/>
+          <a:blip r:embed="rId4"/>
           <a:stretch>
             <a:fillRect/>
           </a:stretch>
@@ -7032,7 +7032,7 @@
         <p:spPr>
           <a:xfrm>
             <a:off x="512064" y="1060704"/>
-            <a:ext cx="11164824" cy="5300677"/>
+            <a:ext cx="11164824" cy="5151508"/>
           </a:xfrm>
           <a:prstGeom prst="rect">
             <a:avLst/>

</xml_diff>

<commit_message>
docs: deck wrap-up after the demo, architecture last, What to watch for folded into Act 1
New slide 4 "What you just saw" (three takeaways and a call-to-action placeholder) after the live demo; How it's built moves to slide 5 and Backup stays last. Rehearsal notes: intro 2 min, acts one minute earlier, close 2 min, the three watch cues said live in Act 1's first 30 seconds.
</commit_message>
<xml_diff>
--- a/docs/demo/agentic-ai-for-earth-intro.pptx
+++ b/docs/demo/agentic-ai-for-earth-intro.pptx
@@ -8,8 +8,8 @@
     <p:sldId id="256" r:id="rId8"/>
     <p:sldId id="257" r:id="rId9"/>
     <p:sldId id="258" r:id="rId10"/>
+    <p:sldId id="262" r:id="rId14"/>
     <p:sldId id="259" r:id="rId11"/>
-    <p:sldId id="260" r:id="rId12"/>
     <p:sldId id="261" r:id="rId13"/>
   </p:sldIdLst>
   <p:sldSz cx="12192000" cy="6858000" type="screen4x3"/>
@@ -839,7 +839,7 @@
                 <a:ea typeface="Atkinson Hyperlegible"/>
                 <a:cs typeface="Atkinson Hyperlegible"/>
               </a:rPr>
-              <a:t>Here’s how that’s built.</a:t>
+              <a:t>Let’s start with the Earth Analyst.</a:t>
             </a:r>
           </a:p>
         </p:txBody>
@@ -927,7 +927,7 @@
                 <a:ea typeface="Atkinson Hyperlegible"/>
                 <a:cs typeface="Atkinson Hyperlegible"/>
               </a:rPr>
-              <a:t>Four agents share one model; the analyst or officer decides.</a:t>
+              <a:t>Four acts, one pattern: the agent does the legwork and drafts; a person decides.</a:t>
             </a:r>
           </a:p>
           <a:p>
@@ -950,7 +950,7 @@
                 <a:ea typeface="Atkinson Hyperlegible"/>
                 <a:cs typeface="Atkinson Hyperlegible"/>
               </a:rPr>
-              <a:t>Left to right. The analyst or officer asks in the web app, a React frontend and API backend on AWS Fargate behind Amazon CloudFront. It goes to one of four Strands agents, each on its own AgentCore runtime. Claude Sonnet 4.6 on Amazon Bedrock is the model the agents use. Along the bottom, the data sources: Sentinel-2 imagery, Sentinel-5P methane, Overture Maps and Clay embeddings from AWS Open Data; NASA’s EMIT plumes and FIRMS fires; Esri’s ArcGIS MCP server, OpenStreetMap, ESA’s Sentinel-1 plans, Sentinel-1 radar from Microsoft Planetary Computer, Global Fishing Watch, USGS LiDAR, the OGIM and GEM registries, and our own S3 bucket. Nothing is filed until the analyst or officer approves; then it goes to S3 and Slack.</a:t>
+              <a:t>Four acts, one pattern. The Earth Analyst looked at a scene before it measured, and turned down a cloudy one. The AI Archaeologist chose its own line to measure across an Octagon wall. Methane Watch followed a satellite tip, checked it with a sharper instrument, and told us what it could not confirm. Dark Vessels chose its radar pass, checked whether a silence could mean anything there, predicted where to look and drafted a patrol; the officer decided whether it goes. Not every step was the model choosing live: some of the data was prepared ahead of time, and I’ve pointed out which. Each agent is its own runtime on Amazon Bedrock AgentCore, on one shared map. The agent does the legwork and drafts; a person decides. [Your call to action]</a:t>
             </a:r>
           </a:p>
           <a:p>
@@ -973,7 +973,7 @@
                 <a:ea typeface="Atkinson Hyperlegible"/>
                 <a:cs typeface="Atkinson Hyperlegible"/>
               </a:rPr>
-              <a:t>So, what to watch for.</a:t>
+              <a:t>Here’s how it’s built.</a:t>
             </a:r>
           </a:p>
         </p:txBody>
@@ -1061,7 +1061,7 @@
                 <a:ea typeface="Atkinson Hyperlegible"/>
                 <a:cs typeface="Atkinson Hyperlegible"/>
               </a:rPr>
-              <a:t>Steps, evidence, and nothing filed until a person approves; the show ends on the officer’s call.</a:t>
+              <a:t>Four agents share one model; the analyst or officer decides.</a:t>
             </a:r>
           </a:p>
           <a:p>
@@ -1084,7 +1084,7 @@
                 <a:ea typeface="Atkinson Hyperlegible"/>
                 <a:cs typeface="Atkinson Hyperlegible"/>
               </a:rPr>
-              <a:t>Three things to watch. On the left, the agent’s steps, lit one at a time, with the images it looked at. In the middle, the map: each layer it lands is evidence you can check. And the moment a person decides. In the methane act, I’ll play the analyst and decide whether to file the draft brief. The last act, Dark Vessels, ends on the agent’s own choices, each with its reason, then a prediction of where to look next, checked against past radar days, and a draft patrol tasking. I’ll play the officer and decide whether to approve it.</a:t>
+              <a:t>Left to right. The analyst or officer asks in the web app, a React frontend and API backend on AWS Fargate behind Amazon CloudFront. It goes to one of four Strands agents, each on its own AgentCore runtime. Claude Sonnet 4.6 on Amazon Bedrock is the model the agents use. Along the bottom, the data sources: Sentinel-2 imagery, Sentinel-5P methane, Overture Maps and Clay embeddings from AWS Open Data; NASA’s EMIT plumes and FIRMS fires; Esri’s ArcGIS MCP server, OpenStreetMap, ESA’s Sentinel-1 plans, Sentinel-1 radar from Microsoft Planetary Computer, Global Fishing Watch, USGS LiDAR, the OGIM and GEM registries, and our own S3 bucket. Nothing is filed until the analyst or officer approves; then it goes to S3 and Slack.</a:t>
             </a:r>
           </a:p>
           <a:p>
@@ -1107,7 +1107,7 @@
                 <a:ea typeface="Atkinson Hyperlegible"/>
                 <a:cs typeface="Atkinson Hyperlegible"/>
               </a:rPr>
-              <a:t>Let’s start with the Earth Analyst.</a:t>
+              <a:t>Happy to take questions.</a:t>
             </a:r>
           </a:p>
         </p:txBody>
@@ -5742,49 +5742,257 @@
                 <a:ea typeface="Atkinson Hyperlegible"/>
                 <a:cs typeface="Atkinson Hyperlegible"/>
               </a:rPr>
-              <a:t>How it’s built</a:t>
-            </a:r>
-          </a:p>
-        </p:txBody>
-      </p:sp>
-      <p:sp>
-        <p:nvSpPr>
-          <p:cNvPr id="3" name="Diagram panel"/>
+              <a:t>What you just saw</a:t>
+            </a:r>
+          </a:p>
+        </p:txBody>
+      </p:sp>
+      <p:sp>
+        <p:nvSpPr>
+          <p:cNvPr id="3" name="Saw 1"/>
+          <p:cNvSpPr txBox="1"/>
+          <p:nvPr/>
+        </p:nvSpPr>
+        <p:spPr>
+          <a:xfrm>
+            <a:off x="1280160" y="1783080"/>
+            <a:ext cx="10180015" cy="1024128"/>
+          </a:xfrm>
+          <a:prstGeom prst="rect">
+            <a:avLst/>
+          </a:prstGeom>
+          <a:noFill/>
+        </p:spPr>
+        <p:txBody>
+          <a:bodyPr wrap="square" lIns="0" rIns="0" tIns="0" bIns="0" anchor="t">
+            <a:noAutofit/>
+          </a:bodyPr>
+          <a:lstStyle/>
+          <a:p>
+            <a:pPr algn="l">
+              <a:lnSpc>
+                <a:spcPct val="100000"/>
+              </a:lnSpc>
+              <a:spcBef>
+                <a:spcPts val="0"/>
+              </a:spcBef>
+              <a:spcAft>
+                <a:spcPts val="0"/>
+              </a:spcAft>
+            </a:pPr>
+            <a:r>
+              <a:rPr sz="3200" b="0" lang="en-GB">
+                <a:solidFill>
+                  <a:srgbClr val="E9EEF3"/>
+                </a:solidFill>
+                <a:latin typeface="Atkinson Hyperlegible"/>
+                <a:ea typeface="Atkinson Hyperlegible"/>
+                <a:cs typeface="Atkinson Hyperlegible"/>
+              </a:rPr>
+              <a:t>The agents chose their tools,</a:t>
+            </a:r>
+            <a:br>
+              <a:rPr sz="3200" b="0" lang="en-GB">
+                <a:solidFill>
+                  <a:srgbClr val="E9EEF3"/>
+                </a:solidFill>
+                <a:latin typeface="Atkinson Hyperlegible"/>
+                <a:ea typeface="Atkinson Hyperlegible"/>
+                <a:cs typeface="Atkinson Hyperlegible"/>
+              </a:rPr>
+            </a:br>
+            <a:r>
+              <a:rPr sz="3200" b="0" lang="en-GB">
+                <a:solidFill>
+                  <a:srgbClr val="E9EEF3"/>
+                </a:solidFill>
+                <a:latin typeface="Atkinson Hyperlegible"/>
+                <a:ea typeface="Atkinson Hyperlegible"/>
+                <a:cs typeface="Atkinson Hyperlegible"/>
+              </a:rPr>
+              <a:t>looked before they measured, and showed their reasons</a:t>
+            </a:r>
+          </a:p>
+        </p:txBody>
+      </p:sp>
+      <p:sp>
+        <p:nvSpPr>
+          <p:cNvPr id="4" name="Saw 2"/>
+          <p:cNvSpPr txBox="1"/>
+          <p:nvPr/>
+        </p:nvSpPr>
+        <p:spPr>
+          <a:xfrm>
+            <a:off x="1280160" y="3108960"/>
+            <a:ext cx="10180015" cy="1024128"/>
+          </a:xfrm>
+          <a:prstGeom prst="rect">
+            <a:avLst/>
+          </a:prstGeom>
+          <a:noFill/>
+        </p:spPr>
+        <p:txBody>
+          <a:bodyPr wrap="square" lIns="0" rIns="0" tIns="0" bIns="0" anchor="t">
+            <a:noAutofit/>
+          </a:bodyPr>
+          <a:lstStyle/>
+          <a:p>
+            <a:pPr algn="l">
+              <a:lnSpc>
+                <a:spcPct val="100000"/>
+              </a:lnSpc>
+              <a:spcBef>
+                <a:spcPts val="0"/>
+              </a:spcBef>
+              <a:spcAft>
+                <a:spcPts val="0"/>
+              </a:spcAft>
+            </a:pPr>
+            <a:r>
+              <a:rPr sz="3200" b="0" lang="en-GB">
+                <a:solidFill>
+                  <a:srgbClr val="E9EEF3"/>
+                </a:solidFill>
+                <a:latin typeface="Atkinson Hyperlegible"/>
+                <a:ea typeface="Atkinson Hyperlegible"/>
+                <a:cs typeface="Atkinson Hyperlegible"/>
+              </a:rPr>
+              <a:t>The agent does the legwork and drafts;</a:t>
+            </a:r>
+            <a:br>
+              <a:rPr sz="3200" b="0" lang="en-GB">
+                <a:solidFill>
+                  <a:srgbClr val="E9EEF3"/>
+                </a:solidFill>
+                <a:latin typeface="Atkinson Hyperlegible"/>
+                <a:ea typeface="Atkinson Hyperlegible"/>
+                <a:cs typeface="Atkinson Hyperlegible"/>
+              </a:rPr>
+            </a:br>
+            <a:r>
+              <a:rPr sz="3200" b="0" lang="en-GB">
+                <a:solidFill>
+                  <a:srgbClr val="E9EEF3"/>
+                </a:solidFill>
+                <a:latin typeface="Atkinson Hyperlegible"/>
+                <a:ea typeface="Atkinson Hyperlegible"/>
+                <a:cs typeface="Atkinson Hyperlegible"/>
+              </a:rPr>
+              <a:t>the analyst or officer decides</a:t>
+            </a:r>
+          </a:p>
+        </p:txBody>
+      </p:sp>
+      <p:sp>
+        <p:nvSpPr>
+          <p:cNvPr id="5" name="Saw 3"/>
+          <p:cNvSpPr txBox="1"/>
+          <p:nvPr/>
+        </p:nvSpPr>
+        <p:spPr>
+          <a:xfrm>
+            <a:off x="1280160" y="4434840"/>
+            <a:ext cx="10180015" cy="1024128"/>
+          </a:xfrm>
+          <a:prstGeom prst="rect">
+            <a:avLst/>
+          </a:prstGeom>
+          <a:noFill/>
+        </p:spPr>
+        <p:txBody>
+          <a:bodyPr wrap="square" lIns="0" rIns="0" tIns="0" bIns="0" anchor="t">
+            <a:noAutofit/>
+          </a:bodyPr>
+          <a:lstStyle/>
+          <a:p>
+            <a:pPr algn="l">
+              <a:lnSpc>
+                <a:spcPct val="100000"/>
+              </a:lnSpc>
+              <a:spcBef>
+                <a:spcPts val="0"/>
+              </a:spcBef>
+              <a:spcAft>
+                <a:spcPts val="0"/>
+              </a:spcAft>
+            </a:pPr>
+            <a:r>
+              <a:rPr sz="3200" b="0" lang="en-GB">
+                <a:solidFill>
+                  <a:srgbClr val="E9EEF3"/>
+                </a:solidFill>
+                <a:latin typeface="Atkinson Hyperlegible"/>
+                <a:ea typeface="Atkinson Hyperlegible"/>
+                <a:cs typeface="Atkinson Hyperlegible"/>
+              </a:rPr>
+              <a:t>One platform: each agent is its own runtime</a:t>
+            </a:r>
+            <a:br>
+              <a:rPr sz="3200" b="0" lang="en-GB">
+                <a:solidFill>
+                  <a:srgbClr val="E9EEF3"/>
+                </a:solidFill>
+                <a:latin typeface="Atkinson Hyperlegible"/>
+                <a:ea typeface="Atkinson Hyperlegible"/>
+                <a:cs typeface="Atkinson Hyperlegible"/>
+              </a:rPr>
+            </a:br>
+            <a:r>
+              <a:rPr sz="3200" b="0" lang="en-GB">
+                <a:solidFill>
+                  <a:srgbClr val="E9EEF3"/>
+                </a:solidFill>
+                <a:latin typeface="Atkinson Hyperlegible"/>
+                <a:ea typeface="Atkinson Hyperlegible"/>
+                <a:cs typeface="Atkinson Hyperlegible"/>
+              </a:rPr>
+              <a:t>on Amazon Bedrock AgentCore</a:t>
+            </a:r>
+          </a:p>
+        </p:txBody>
+      </p:sp>
+      <p:cxnSp>
+        <p:nvCxnSpPr>
+          <p:cNvPr id="6" name="Saw rail"/>
+          <p:cNvCxnSpPr/>
+          <p:nvPr/>
+        </p:nvCxnSpPr>
+        <p:spPr>
+          <a:xfrm>
+            <a:off x="841248" y="2067458"/>
+            <a:ext cx="0" cy="2651760"/>
+          </a:xfrm>
+          <a:prstGeom prst="line">
+            <a:avLst/>
+          </a:prstGeom>
+          <a:ln w="19050">
+            <a:solidFill>
+              <a:srgbClr val="43484F"/>
+            </a:solidFill>
+          </a:ln>
+        </p:spPr>
+      </p:cxnSp>
+      <p:sp>
+        <p:nvSpPr>
+          <p:cNvPr id="7" name="Saw dot 1"/>
           <p:cNvSpPr/>
           <p:nvPr/>
         </p:nvSpPr>
         <p:spPr>
           <a:xfrm>
-            <a:off x="280415" y="1371600"/>
-            <a:ext cx="11631167" cy="5140105"/>
-          </a:xfrm>
-          <a:prstGeom prst="roundRect">
-            <a:avLst>
-              <a:gd name="adj" fmla="val 2134"/>
-            </a:avLst>
+            <a:off x="749808" y="1976018"/>
+            <a:ext cx="182880" cy="182880"/>
+          </a:xfrm>
+          <a:prstGeom prst="ellipse">
+            <a:avLst/>
           </a:prstGeom>
           <a:solidFill>
-            <a:srgbClr val="FFFFFF"/>
+            <a:srgbClr val="8FA3B8"/>
           </a:solidFill>
           <a:ln>
             <a:noFill/>
           </a:ln>
-          <a:effectLst/>
-        </p:spPr>
-        <p:style>
-          <a:lnRef idx="1">
-            <a:schemeClr val="accent1"/>
-          </a:lnRef>
-          <a:fillRef idx="3">
-            <a:schemeClr val="accent1"/>
-          </a:fillRef>
-          <a:effectRef idx="2">
-            <a:schemeClr val="accent1"/>
-          </a:effectRef>
-          <a:fontRef idx="minor">
-            <a:schemeClr val="lt1"/>
-          </a:fontRef>
-        </p:style>
+        </p:spPr>
         <p:txBody>
           <a:bodyPr rtlCol="0" anchor="ctr"/>
           <a:lstStyle/>
@@ -5793,30 +6001,111 @@
           </a:p>
         </p:txBody>
       </p:sp>
-      <p:pic>
-        <p:nvPicPr>
-          <p:cNvPr id="4" name="Architecture diagram" descr="Architecture, left to right. The analyst or officer asks and approves in the web app: Amazon CloudFront in front of a React frontend and API backend on AWS Fargate. The web app invokes four agents in one Amazon Bedrock AgentCore group, one runtime each: Earth Analyst, AI Archaeologist, Methane Hunter and Dark Vessels. The agents make model calls to Claude Sonnet 4.6, in its own Amazon Bedrock box. The agents read the data sources: Amazon S3 sessions and caches; NASA EMIT methane plumes and FIRMS active fires; AWS Open Data Sentinel-2 imagery, Sentinel-5P methane, Overture Maps and Clay v1.5 embeddings via a Lambda fan-out; and other providers: Esri ArcGIS MCP server, OpenStreetMap, ESA Sentinel-1 plans, Global Fishing Watch, USGS 3DEP LiDAR, OGIM and GEM registries, and Sentinel-1 radar via Microsoft Planetary Computer. On approval the web app files to Amazon S3 and posts to Slack."/>
-          <p:cNvPicPr>
-            <a:picLocks noChangeAspect="1"/>
-          </p:cNvPicPr>
+      <p:sp>
+        <p:nvSpPr>
+          <p:cNvPr id="8" name="Saw dot 2"/>
+          <p:cNvSpPr/>
           <p:nvPr/>
-        </p:nvPicPr>
-        <p:blipFill>
-          <a:blip r:embed="rId4"/>
-          <a:stretch>
-            <a:fillRect/>
-          </a:stretch>
-        </p:blipFill>
-        <p:spPr>
-          <a:xfrm>
-            <a:off x="335279" y="1426464"/>
-            <a:ext cx="11521440" cy="5030377"/>
+        </p:nvSpPr>
+        <p:spPr>
+          <a:xfrm>
+            <a:off x="731520" y="3283610"/>
+            <a:ext cx="219456" cy="219456"/>
+          </a:xfrm>
+          <a:prstGeom prst="ellipse">
+            <a:avLst/>
+          </a:prstGeom>
+          <a:solidFill>
+            <a:srgbClr val="F5A524"/>
+          </a:solidFill>
+          <a:ln>
+            <a:noFill/>
+          </a:ln>
+        </p:spPr>
+        <p:txBody>
+          <a:bodyPr rtlCol="0" anchor="ctr"/>
+          <a:lstStyle/>
+          <a:p>
+            <a:pPr algn="ctr"/>
+          </a:p>
+        </p:txBody>
+      </p:sp>
+      <p:sp>
+        <p:nvSpPr>
+          <p:cNvPr id="9" name="Saw dot 3"/>
+          <p:cNvSpPr/>
+          <p:nvPr/>
+        </p:nvSpPr>
+        <p:spPr>
+          <a:xfrm>
+            <a:off x="749808" y="4627778"/>
+            <a:ext cx="182880" cy="182880"/>
+          </a:xfrm>
+          <a:prstGeom prst="ellipse">
+            <a:avLst/>
+          </a:prstGeom>
+          <a:solidFill>
+            <a:srgbClr val="8FA3B8"/>
+          </a:solidFill>
+          <a:ln>
+            <a:noFill/>
+          </a:ln>
+        </p:spPr>
+        <p:txBody>
+          <a:bodyPr rtlCol="0" anchor="ctr"/>
+          <a:lstStyle/>
+          <a:p>
+            <a:pPr algn="ctr"/>
+          </a:p>
+        </p:txBody>
+      </p:sp>
+      <p:sp>
+        <p:nvSpPr>
+          <p:cNvPr id="10" name="Call to action"/>
+          <p:cNvSpPr txBox="1"/>
+          <p:nvPr/>
+        </p:nvSpPr>
+        <p:spPr>
+          <a:xfrm>
+            <a:off x="731520" y="5852160"/>
+            <a:ext cx="10728655" cy="411480"/>
           </a:xfrm>
           <a:prstGeom prst="rect">
             <a:avLst/>
           </a:prstGeom>
-        </p:spPr>
-      </p:pic>
+          <a:noFill/>
+        </p:spPr>
+        <p:txBody>
+          <a:bodyPr wrap="square" lIns="0" rIns="0" tIns="0" bIns="0" anchor="t">
+            <a:noAutofit/>
+          </a:bodyPr>
+          <a:lstStyle/>
+          <a:p>
+            <a:pPr algn="l">
+              <a:lnSpc>
+                <a:spcPct val="110000"/>
+              </a:lnSpc>
+              <a:spcBef>
+                <a:spcPts val="0"/>
+              </a:spcBef>
+              <a:spcAft>
+                <a:spcPts val="0"/>
+              </a:spcAft>
+            </a:pPr>
+            <a:r>
+              <a:rPr sz="2400" b="0" lang="en-GB">
+                <a:solidFill>
+                  <a:srgbClr val="8FA3B8"/>
+                </a:solidFill>
+                <a:latin typeface="Atkinson Hyperlegible"/>
+                <a:ea typeface="Atkinson Hyperlegible"/>
+                <a:cs typeface="Atkinson Hyperlegible"/>
+              </a:rPr>
+              <a:t>[Your call to action]</a:t>
+            </a:r>
+          </a:p>
+        </p:txBody>
+      </p:sp>
     </p:spTree>
   </p:cSld>
   <p:clrMapOvr>
@@ -5889,1009 +6178,81 @@
                 <a:ea typeface="Atkinson Hyperlegible"/>
                 <a:cs typeface="Atkinson Hyperlegible"/>
               </a:rPr>
-              <a:t>What to watch for</a:t>
-            </a:r>
-          </a:p>
-        </p:txBody>
-      </p:sp>
-      <p:sp>
-        <p:nvSpPr>
-          <p:cNvPr id="3" name="Watch marker 1"/>
+              <a:t>How it’s built</a:t>
+            </a:r>
+          </a:p>
+        </p:txBody>
+      </p:sp>
+      <p:sp>
+        <p:nvSpPr>
+          <p:cNvPr id="3" name="Diagram panel"/>
           <p:cNvSpPr/>
           <p:nvPr/>
         </p:nvSpPr>
         <p:spPr>
           <a:xfrm>
-            <a:off x="731520" y="2167128"/>
-            <a:ext cx="420624" cy="420624"/>
-          </a:xfrm>
-          <a:prstGeom prst="ellipse">
-            <a:avLst/>
+            <a:off x="280415" y="1371600"/>
+            <a:ext cx="11631167" cy="5140105"/>
+          </a:xfrm>
+          <a:prstGeom prst="roundRect">
+            <a:avLst>
+              <a:gd name="adj" fmla="val 2134"/>
+            </a:avLst>
           </a:prstGeom>
           <a:solidFill>
-            <a:srgbClr val="1D2530"/>
-          </a:solidFill>
-          <a:ln w="12700">
-            <a:solidFill>
-              <a:srgbClr val="43484F"/>
-            </a:solidFill>
-          </a:ln>
-        </p:spPr>
-        <p:txBody>
-          <a:bodyPr rtlCol="0" anchor="ctr" lIns="0" rIns="0" tIns="0" bIns="0" wrap="none"/>
-          <a:lstStyle/>
-          <a:p>
-            <a:pPr algn="ctr"/>
-            <a:r>
-              <a:rPr sz="2000" b="1" lang="en-GB">
-                <a:solidFill>
-                  <a:srgbClr val="E9EEF3"/>
-                </a:solidFill>
-                <a:latin typeface="Menlo"/>
-                <a:ea typeface="Menlo"/>
-                <a:cs typeface="Menlo"/>
-              </a:rPr>
-              <a:t>1</a:t>
-            </a:r>
-          </a:p>
-        </p:txBody>
-      </p:sp>
-      <p:sp>
-        <p:nvSpPr>
-          <p:cNvPr id="4" name="Watch 1"/>
-          <p:cNvSpPr txBox="1"/>
-          <p:nvPr/>
-        </p:nvSpPr>
-        <p:spPr>
-          <a:xfrm>
-            <a:off x="1417320" y="2157984"/>
-            <a:ext cx="5257800" cy="457200"/>
-          </a:xfrm>
-          <a:prstGeom prst="rect">
-            <a:avLst/>
-          </a:prstGeom>
-          <a:noFill/>
-        </p:spPr>
-        <p:txBody>
-          <a:bodyPr wrap="square" lIns="0" rIns="0" tIns="0" bIns="0" anchor="t">
-            <a:noAutofit/>
-          </a:bodyPr>
-          <a:lstStyle/>
-          <a:p>
-            <a:pPr algn="l">
-              <a:lnSpc>
-                <a:spcPct val="100000"/>
-              </a:lnSpc>
-              <a:spcBef>
-                <a:spcPts val="0"/>
-              </a:spcBef>
-              <a:spcAft>
-                <a:spcPts val="0"/>
-              </a:spcAft>
-            </a:pPr>
-            <a:r>
-              <a:rPr sz="2400" b="0" lang="en-GB">
-                <a:solidFill>
-                  <a:srgbClr val="E9EEF3"/>
-                </a:solidFill>
-                <a:latin typeface="Atkinson Hyperlegible"/>
-                <a:ea typeface="Atkinson Hyperlegible"/>
-                <a:cs typeface="Atkinson Hyperlegible"/>
-              </a:rPr>
-              <a:t>The agent’s steps, on the left</a:t>
-            </a:r>
-          </a:p>
-        </p:txBody>
-      </p:sp>
-      <p:sp>
-        <p:nvSpPr>
-          <p:cNvPr id="5" name="Watch marker 2"/>
-          <p:cNvSpPr/>
-          <p:nvPr/>
-        </p:nvSpPr>
-        <p:spPr>
-          <a:xfrm>
-            <a:off x="731520" y="3264408"/>
-            <a:ext cx="420624" cy="420624"/>
-          </a:xfrm>
-          <a:prstGeom prst="ellipse">
-            <a:avLst/>
-          </a:prstGeom>
-          <a:solidFill>
-            <a:srgbClr val="1D2530"/>
-          </a:solidFill>
-          <a:ln w="12700">
-            <a:solidFill>
-              <a:srgbClr val="43484F"/>
-            </a:solidFill>
-          </a:ln>
-        </p:spPr>
-        <p:txBody>
-          <a:bodyPr rtlCol="0" anchor="ctr" lIns="0" rIns="0" tIns="0" bIns="0" wrap="none"/>
-          <a:lstStyle/>
-          <a:p>
-            <a:pPr algn="ctr"/>
-            <a:r>
-              <a:rPr sz="2000" b="1" lang="en-GB">
-                <a:solidFill>
-                  <a:srgbClr val="E9EEF3"/>
-                </a:solidFill>
-                <a:latin typeface="Menlo"/>
-                <a:ea typeface="Menlo"/>
-                <a:cs typeface="Menlo"/>
-              </a:rPr>
-              <a:t>2</a:t>
-            </a:r>
-          </a:p>
-        </p:txBody>
-      </p:sp>
-      <p:sp>
-        <p:nvSpPr>
-          <p:cNvPr id="6" name="Watch 2"/>
-          <p:cNvSpPr txBox="1"/>
-          <p:nvPr/>
-        </p:nvSpPr>
-        <p:spPr>
-          <a:xfrm>
-            <a:off x="1417320" y="3255263"/>
-            <a:ext cx="5257800" cy="457200"/>
-          </a:xfrm>
-          <a:prstGeom prst="rect">
-            <a:avLst/>
-          </a:prstGeom>
-          <a:noFill/>
-        </p:spPr>
-        <p:txBody>
-          <a:bodyPr wrap="square" lIns="0" rIns="0" tIns="0" bIns="0" anchor="t">
-            <a:noAutofit/>
-          </a:bodyPr>
-          <a:lstStyle/>
-          <a:p>
-            <a:pPr algn="l">
-              <a:lnSpc>
-                <a:spcPct val="100000"/>
-              </a:lnSpc>
-              <a:spcBef>
-                <a:spcPts val="0"/>
-              </a:spcBef>
-              <a:spcAft>
-                <a:spcPts val="0"/>
-              </a:spcAft>
-            </a:pPr>
-            <a:r>
-              <a:rPr sz="2400" b="0" lang="en-GB">
-                <a:solidFill>
-                  <a:srgbClr val="E9EEF3"/>
-                </a:solidFill>
-                <a:latin typeface="Atkinson Hyperlegible"/>
-                <a:ea typeface="Atkinson Hyperlegible"/>
-                <a:cs typeface="Atkinson Hyperlegible"/>
-              </a:rPr>
-              <a:t>The map, where the evidence lands</a:t>
-            </a:r>
-          </a:p>
-        </p:txBody>
-      </p:sp>
-      <p:sp>
-        <p:nvSpPr>
-          <p:cNvPr id="7" name="Watch marker 3"/>
-          <p:cNvSpPr/>
-          <p:nvPr/>
-        </p:nvSpPr>
-        <p:spPr>
-          <a:xfrm>
-            <a:off x="731520" y="4361688"/>
-            <a:ext cx="420624" cy="420624"/>
-          </a:xfrm>
-          <a:prstGeom prst="ellipse">
-            <a:avLst/>
-          </a:prstGeom>
-          <a:solidFill>
-            <a:srgbClr val="F5A524"/>
+            <a:srgbClr val="FFFFFF"/>
           </a:solidFill>
           <a:ln>
             <a:noFill/>
           </a:ln>
-        </p:spPr>
-        <p:txBody>
-          <a:bodyPr rtlCol="0" anchor="ctr" lIns="0" rIns="0" tIns="0" bIns="0" wrap="none"/>
+          <a:effectLst/>
+        </p:spPr>
+        <p:style>
+          <a:lnRef idx="1">
+            <a:schemeClr val="accent1"/>
+          </a:lnRef>
+          <a:fillRef idx="3">
+            <a:schemeClr val="accent1"/>
+          </a:fillRef>
+          <a:effectRef idx="2">
+            <a:schemeClr val="accent1"/>
+          </a:effectRef>
+          <a:fontRef idx="minor">
+            <a:schemeClr val="lt1"/>
+          </a:fontRef>
+        </p:style>
+        <p:txBody>
+          <a:bodyPr rtlCol="0" anchor="ctr"/>
           <a:lstStyle/>
           <a:p>
             <a:pPr algn="ctr"/>
-            <a:r>
-              <a:rPr sz="2000" b="1" lang="en-GB">
-                <a:solidFill>
-                  <a:srgbClr val="0F141B"/>
-                </a:solidFill>
-                <a:latin typeface="Menlo"/>
-                <a:ea typeface="Menlo"/>
-                <a:cs typeface="Menlo"/>
-              </a:rPr>
-              <a:t>3</a:t>
-            </a:r>
-          </a:p>
-        </p:txBody>
-      </p:sp>
-      <p:sp>
-        <p:nvSpPr>
-          <p:cNvPr id="8" name="Watch 3"/>
-          <p:cNvSpPr txBox="1"/>
+          </a:p>
+        </p:txBody>
+      </p:sp>
+      <p:pic>
+        <p:nvPicPr>
+          <p:cNvPr id="4" name="Architecture diagram" descr="Architecture, left to right. The analyst or officer asks and approves in the web app: Amazon CloudFront in front of a React frontend and API backend on AWS Fargate. The web app invokes four agents in one Amazon Bedrock AgentCore group, one runtime each: Earth Analyst, AI Archaeologist, Methane Hunter and Dark Vessels. The agents make model calls to Claude Sonnet 4.6, in its own Amazon Bedrock box. The agents read the data sources: Amazon S3 sessions and caches; NASA EMIT methane plumes and FIRMS active fires; AWS Open Data Sentinel-2 imagery, Sentinel-5P methane, Overture Maps and Clay v1.5 embeddings via a Lambda fan-out; and other providers: Esri ArcGIS MCP server, OpenStreetMap, ESA Sentinel-1 plans, Global Fishing Watch, USGS 3DEP LiDAR, OGIM and GEM registries, and Sentinel-1 radar via Microsoft Planetary Computer. On approval the web app files to Amazon S3 and posts to Slack."/>
+          <p:cNvPicPr>
+            <a:picLocks noChangeAspect="1"/>
+          </p:cNvPicPr>
           <p:nvPr/>
-        </p:nvSpPr>
-        <p:spPr>
-          <a:xfrm>
-            <a:off x="1417320" y="4352544"/>
-            <a:ext cx="5257800" cy="457200"/>
+        </p:nvPicPr>
+        <p:blipFill>
+          <a:blip r:embed="rId4"/>
+          <a:stretch>
+            <a:fillRect/>
+          </a:stretch>
+        </p:blipFill>
+        <p:spPr>
+          <a:xfrm>
+            <a:off x="335279" y="1426464"/>
+            <a:ext cx="11521440" cy="5030377"/>
           </a:xfrm>
           <a:prstGeom prst="rect">
             <a:avLst/>
           </a:prstGeom>
-          <a:noFill/>
-        </p:spPr>
-        <p:txBody>
-          <a:bodyPr wrap="square" lIns="0" rIns="0" tIns="0" bIns="0" anchor="t">
-            <a:noAutofit/>
-          </a:bodyPr>
-          <a:lstStyle/>
-          <a:p>
-            <a:pPr algn="l">
-              <a:lnSpc>
-                <a:spcPct val="100000"/>
-              </a:lnSpc>
-              <a:spcBef>
-                <a:spcPts val="0"/>
-              </a:spcBef>
-              <a:spcAft>
-                <a:spcPts val="0"/>
-              </a:spcAft>
-            </a:pPr>
-            <a:r>
-              <a:rPr sz="2400" b="0" lang="en-GB">
-                <a:solidFill>
-                  <a:srgbClr val="E9EEF3"/>
-                </a:solidFill>
-                <a:latin typeface="Atkinson Hyperlegible"/>
-                <a:ea typeface="Atkinson Hyperlegible"/>
-                <a:cs typeface="Atkinson Hyperlegible"/>
-              </a:rPr>
-              <a:t>The moment a person decides</a:t>
-            </a:r>
-          </a:p>
-        </p:txBody>
-      </p:sp>
-      <p:sp>
-        <p:nvSpPr>
-          <p:cNvPr id="9" name="Stage frame"/>
-          <p:cNvSpPr/>
-          <p:nvPr/>
-        </p:nvSpPr>
-        <p:spPr>
-          <a:xfrm>
-            <a:off x="6949440" y="2206075"/>
-            <a:ext cx="4510735" cy="2537288"/>
-          </a:xfrm>
-          <a:prstGeom prst="roundRect">
-            <a:avLst>
-              <a:gd name="adj" fmla="val 3000"/>
-            </a:avLst>
-          </a:prstGeom>
-          <a:solidFill>
-            <a:srgbClr val="121923"/>
-          </a:solidFill>
-          <a:ln w="12700">
-            <a:solidFill>
-              <a:srgbClr val="43484F"/>
-            </a:solidFill>
-          </a:ln>
-        </p:spPr>
-        <p:txBody>
-          <a:bodyPr rtlCol="0" anchor="ctr"/>
-          <a:lstStyle/>
-          <a:p>
-            <a:pPr algn="ctr"/>
-          </a:p>
-        </p:txBody>
-      </p:sp>
-      <p:sp>
-        <p:nvSpPr>
-          <p:cNvPr id="10" name="Stage rail"/>
-          <p:cNvSpPr/>
-          <p:nvPr/>
-        </p:nvSpPr>
-        <p:spPr>
-          <a:xfrm>
-            <a:off x="6958583" y="2215219"/>
-            <a:ext cx="4492447" cy="182880"/>
-          </a:xfrm>
-          <a:prstGeom prst="rect">
-            <a:avLst/>
-          </a:prstGeom>
-          <a:solidFill>
-            <a:srgbClr val="161C25"/>
-          </a:solidFill>
-          <a:ln>
-            <a:noFill/>
-          </a:ln>
-        </p:spPr>
-        <p:txBody>
-          <a:bodyPr rtlCol="0" anchor="ctr"/>
-          <a:lstStyle/>
-          <a:p>
-            <a:pPr algn="ctr"/>
-          </a:p>
-        </p:txBody>
-      </p:sp>
-      <p:sp>
-        <p:nvSpPr>
-          <p:cNvPr id="11" name="Step column"/>
-          <p:cNvSpPr/>
-          <p:nvPr/>
-        </p:nvSpPr>
-        <p:spPr>
-          <a:xfrm>
-            <a:off x="7077455" y="2516971"/>
-            <a:ext cx="1097280" cy="1970360"/>
-          </a:xfrm>
-          <a:prstGeom prst="roundRect">
-            <a:avLst>
-              <a:gd name="adj" fmla="val 6000"/>
-            </a:avLst>
-          </a:prstGeom>
-          <a:solidFill>
-            <a:srgbClr val="1D2530"/>
-          </a:solidFill>
-          <a:ln w="12700">
-            <a:solidFill>
-              <a:srgbClr val="2E3339"/>
-            </a:solidFill>
-          </a:ln>
-        </p:spPr>
-        <p:txBody>
-          <a:bodyPr rtlCol="0" anchor="ctr"/>
-          <a:lstStyle/>
-          <a:p>
-            <a:pPr algn="ctr"/>
-          </a:p>
-        </p:txBody>
-      </p:sp>
-      <p:sp>
-        <p:nvSpPr>
-          <p:cNvPr id="12" name="Step dot 1"/>
-          <p:cNvSpPr/>
-          <p:nvPr/>
-        </p:nvSpPr>
-        <p:spPr>
-          <a:xfrm>
-            <a:off x="7187183" y="2773003"/>
-            <a:ext cx="73152" cy="73152"/>
-          </a:xfrm>
-          <a:prstGeom prst="ellipse">
-            <a:avLst/>
-          </a:prstGeom>
-          <a:solidFill>
-            <a:srgbClr val="8FA3B8"/>
-          </a:solidFill>
-          <a:ln>
-            <a:noFill/>
-          </a:ln>
-        </p:spPr>
-        <p:txBody>
-          <a:bodyPr rtlCol="0" anchor="ctr"/>
-          <a:lstStyle/>
-          <a:p>
-            <a:pPr algn="ctr"/>
-          </a:p>
-        </p:txBody>
-      </p:sp>
-      <p:sp>
-        <p:nvSpPr>
-          <p:cNvPr id="13" name="Step row 1"/>
-          <p:cNvSpPr/>
-          <p:nvPr/>
-        </p:nvSpPr>
-        <p:spPr>
-          <a:xfrm>
-            <a:off x="7333488" y="2786719"/>
-            <a:ext cx="713232" cy="45720"/>
-          </a:xfrm>
-          <a:prstGeom prst="rect">
-            <a:avLst/>
-          </a:prstGeom>
-          <a:solidFill>
-            <a:srgbClr val="43484F"/>
-          </a:solidFill>
-          <a:ln>
-            <a:noFill/>
-          </a:ln>
-        </p:spPr>
-        <p:txBody>
-          <a:bodyPr rtlCol="0" anchor="ctr"/>
-          <a:lstStyle/>
-          <a:p>
-            <a:pPr algn="ctr"/>
-          </a:p>
-        </p:txBody>
-      </p:sp>
-      <p:sp>
-        <p:nvSpPr>
-          <p:cNvPr id="14" name="Step dot 2"/>
-          <p:cNvSpPr/>
-          <p:nvPr/>
-        </p:nvSpPr>
-        <p:spPr>
-          <a:xfrm>
-            <a:off x="7187183" y="3047323"/>
-            <a:ext cx="73152" cy="73152"/>
-          </a:xfrm>
-          <a:prstGeom prst="ellipse">
-            <a:avLst/>
-          </a:prstGeom>
-          <a:solidFill>
-            <a:srgbClr val="8FA3B8"/>
-          </a:solidFill>
-          <a:ln>
-            <a:noFill/>
-          </a:ln>
-        </p:spPr>
-        <p:txBody>
-          <a:bodyPr rtlCol="0" anchor="ctr"/>
-          <a:lstStyle/>
-          <a:p>
-            <a:pPr algn="ctr"/>
-          </a:p>
-        </p:txBody>
-      </p:sp>
-      <p:sp>
-        <p:nvSpPr>
-          <p:cNvPr id="15" name="Step row 2"/>
-          <p:cNvSpPr/>
-          <p:nvPr/>
-        </p:nvSpPr>
-        <p:spPr>
-          <a:xfrm>
-            <a:off x="7333488" y="3061039"/>
-            <a:ext cx="548640" cy="45720"/>
-          </a:xfrm>
-          <a:prstGeom prst="rect">
-            <a:avLst/>
-          </a:prstGeom>
-          <a:solidFill>
-            <a:srgbClr val="43484F"/>
-          </a:solidFill>
-          <a:ln>
-            <a:noFill/>
-          </a:ln>
-        </p:spPr>
-        <p:txBody>
-          <a:bodyPr rtlCol="0" anchor="ctr"/>
-          <a:lstStyle/>
-          <a:p>
-            <a:pPr algn="ctr"/>
-          </a:p>
-        </p:txBody>
-      </p:sp>
-      <p:sp>
-        <p:nvSpPr>
-          <p:cNvPr id="16" name="Step dot 3"/>
-          <p:cNvSpPr/>
-          <p:nvPr/>
-        </p:nvSpPr>
-        <p:spPr>
-          <a:xfrm>
-            <a:off x="7187183" y="3321643"/>
-            <a:ext cx="73152" cy="73152"/>
-          </a:xfrm>
-          <a:prstGeom prst="ellipse">
-            <a:avLst/>
-          </a:prstGeom>
-          <a:solidFill>
-            <a:srgbClr val="8FA3B8"/>
-          </a:solidFill>
-          <a:ln>
-            <a:noFill/>
-          </a:ln>
-        </p:spPr>
-        <p:txBody>
-          <a:bodyPr rtlCol="0" anchor="ctr"/>
-          <a:lstStyle/>
-          <a:p>
-            <a:pPr algn="ctr"/>
-          </a:p>
-        </p:txBody>
-      </p:sp>
-      <p:sp>
-        <p:nvSpPr>
-          <p:cNvPr id="17" name="Step row 3"/>
-          <p:cNvSpPr/>
-          <p:nvPr/>
-        </p:nvSpPr>
-        <p:spPr>
-          <a:xfrm>
-            <a:off x="7333488" y="3335359"/>
-            <a:ext cx="713232" cy="45720"/>
-          </a:xfrm>
-          <a:prstGeom prst="rect">
-            <a:avLst/>
-          </a:prstGeom>
-          <a:solidFill>
-            <a:srgbClr val="43484F"/>
-          </a:solidFill>
-          <a:ln>
-            <a:noFill/>
-          </a:ln>
-        </p:spPr>
-        <p:txBody>
-          <a:bodyPr rtlCol="0" anchor="ctr"/>
-          <a:lstStyle/>
-          <a:p>
-            <a:pPr algn="ctr"/>
-          </a:p>
-        </p:txBody>
-      </p:sp>
-      <p:sp>
-        <p:nvSpPr>
-          <p:cNvPr id="18" name="Step dot 4"/>
-          <p:cNvSpPr/>
-          <p:nvPr/>
-        </p:nvSpPr>
-        <p:spPr>
-          <a:xfrm>
-            <a:off x="7187183" y="3595963"/>
-            <a:ext cx="73152" cy="73152"/>
-          </a:xfrm>
-          <a:prstGeom prst="ellipse">
-            <a:avLst/>
-          </a:prstGeom>
-          <a:solidFill>
-            <a:srgbClr val="E9EEF3"/>
-          </a:solidFill>
-          <a:ln>
-            <a:noFill/>
-          </a:ln>
-        </p:spPr>
-        <p:txBody>
-          <a:bodyPr rtlCol="0" anchor="ctr"/>
-          <a:lstStyle/>
-          <a:p>
-            <a:pPr algn="ctr"/>
-          </a:p>
-        </p:txBody>
-      </p:sp>
-      <p:sp>
-        <p:nvSpPr>
-          <p:cNvPr id="19" name="Step row 4"/>
-          <p:cNvSpPr/>
-          <p:nvPr/>
-        </p:nvSpPr>
-        <p:spPr>
-          <a:xfrm>
-            <a:off x="7333488" y="3609679"/>
-            <a:ext cx="548640" cy="45720"/>
-          </a:xfrm>
-          <a:prstGeom prst="rect">
-            <a:avLst/>
-          </a:prstGeom>
-          <a:solidFill>
-            <a:srgbClr val="E9EEF3"/>
-          </a:solidFill>
-          <a:ln>
-            <a:noFill/>
-          </a:ln>
-        </p:spPr>
-        <p:txBody>
-          <a:bodyPr rtlCol="0" anchor="ctr"/>
-          <a:lstStyle/>
-          <a:p>
-            <a:pPr algn="ctr"/>
-          </a:p>
-        </p:txBody>
-      </p:sp>
-      <p:sp>
-        <p:nvSpPr>
-          <p:cNvPr id="20" name="Step dot 5"/>
-          <p:cNvSpPr/>
-          <p:nvPr/>
-        </p:nvSpPr>
-        <p:spPr>
-          <a:xfrm>
-            <a:off x="7187183" y="3870283"/>
-            <a:ext cx="73152" cy="73152"/>
-          </a:xfrm>
-          <a:prstGeom prst="ellipse">
-            <a:avLst/>
-          </a:prstGeom>
-          <a:solidFill>
-            <a:srgbClr val="8FA3B8"/>
-          </a:solidFill>
-          <a:ln>
-            <a:noFill/>
-          </a:ln>
-        </p:spPr>
-        <p:txBody>
-          <a:bodyPr rtlCol="0" anchor="ctr"/>
-          <a:lstStyle/>
-          <a:p>
-            <a:pPr algn="ctr"/>
-          </a:p>
-        </p:txBody>
-      </p:sp>
-      <p:sp>
-        <p:nvSpPr>
-          <p:cNvPr id="21" name="Step row 5"/>
-          <p:cNvSpPr/>
-          <p:nvPr/>
-        </p:nvSpPr>
-        <p:spPr>
-          <a:xfrm>
-            <a:off x="7333488" y="3883999"/>
-            <a:ext cx="713232" cy="45720"/>
-          </a:xfrm>
-          <a:prstGeom prst="rect">
-            <a:avLst/>
-          </a:prstGeom>
-          <a:solidFill>
-            <a:srgbClr val="43484F"/>
-          </a:solidFill>
-          <a:ln>
-            <a:noFill/>
-          </a:ln>
-        </p:spPr>
-        <p:txBody>
-          <a:bodyPr rtlCol="0" anchor="ctr"/>
-          <a:lstStyle/>
-          <a:p>
-            <a:pPr algn="ctr"/>
-          </a:p>
-        </p:txBody>
-      </p:sp>
-      <p:sp>
-        <p:nvSpPr>
-          <p:cNvPr id="22" name="Step dot 6"/>
-          <p:cNvSpPr/>
-          <p:nvPr/>
-        </p:nvSpPr>
-        <p:spPr>
-          <a:xfrm>
-            <a:off x="7187183" y="4144603"/>
-            <a:ext cx="73152" cy="73152"/>
-          </a:xfrm>
-          <a:prstGeom prst="ellipse">
-            <a:avLst/>
-          </a:prstGeom>
-          <a:solidFill>
-            <a:srgbClr val="8FA3B8"/>
-          </a:solidFill>
-          <a:ln>
-            <a:noFill/>
-          </a:ln>
-        </p:spPr>
-        <p:txBody>
-          <a:bodyPr rtlCol="0" anchor="ctr"/>
-          <a:lstStyle/>
-          <a:p>
-            <a:pPr algn="ctr"/>
-          </a:p>
-        </p:txBody>
-      </p:sp>
-      <p:sp>
-        <p:nvSpPr>
-          <p:cNvPr id="23" name="Step row 6"/>
-          <p:cNvSpPr/>
-          <p:nvPr/>
-        </p:nvSpPr>
-        <p:spPr>
-          <a:xfrm>
-            <a:off x="7333488" y="4158319"/>
-            <a:ext cx="548640" cy="45720"/>
-          </a:xfrm>
-          <a:prstGeom prst="rect">
-            <a:avLst/>
-          </a:prstGeom>
-          <a:solidFill>
-            <a:srgbClr val="43484F"/>
-          </a:solidFill>
-          <a:ln>
-            <a:noFill/>
-          </a:ln>
-        </p:spPr>
-        <p:txBody>
-          <a:bodyPr rtlCol="0" anchor="ctr"/>
-          <a:lstStyle/>
-          <a:p>
-            <a:pPr algn="ctr"/>
-          </a:p>
-        </p:txBody>
-      </p:sp>
-      <p:sp>
-        <p:nvSpPr>
-          <p:cNvPr id="24" name="Evidence outline"/>
-          <p:cNvSpPr/>
-          <p:nvPr/>
-        </p:nvSpPr>
-        <p:spPr>
-          <a:xfrm>
-            <a:off x="9098280" y="2846155"/>
-            <a:ext cx="1828800" cy="1371600"/>
-          </a:xfrm>
-          <a:custGeom>
-            <a:avLst/>
-            <a:gdLst/>
-            <a:ahLst/>
-            <a:cxnLst/>
-            <a:rect l="l" t="t" r="r" b="b"/>
-            <a:pathLst>
-              <a:path w="1828800" h="1371600">
-                <a:moveTo>
-                  <a:pt x="182879" y="137160"/>
-                </a:moveTo>
-                <a:lnTo>
-                  <a:pt x="1143000" y="0"/>
-                </a:lnTo>
-                <a:lnTo>
-                  <a:pt x="1828800" y="502920"/>
-                </a:lnTo>
-                <a:lnTo>
-                  <a:pt x="1600200" y="1234440"/>
-                </a:lnTo>
-                <a:lnTo>
-                  <a:pt x="594360" y="1371600"/>
-                </a:lnTo>
-                <a:lnTo>
-                  <a:pt x="0" y="822960"/>
-                </a:lnTo>
-                <a:close/>
-              </a:path>
-            </a:pathLst>
-          </a:custGeom>
-          <a:noFill/>
-          <a:ln w="19050">
-            <a:solidFill>
-              <a:srgbClr val="E9EEF3"/>
-            </a:solidFill>
-            <a:prstDash val="dash"/>
-          </a:ln>
-        </p:spPr>
-        <p:txBody>
-          <a:bodyPr rtlCol="0" anchor="ctr"/>
-          <a:lstStyle/>
-          <a:p>
-            <a:pPr algn="ctr"/>
-          </a:p>
-        </p:txBody>
-      </p:sp>
-      <p:sp>
-        <p:nvSpPr>
-          <p:cNvPr id="25" name="Evidence site"/>
-          <p:cNvSpPr/>
-          <p:nvPr/>
-        </p:nvSpPr>
-        <p:spPr>
-          <a:xfrm>
-            <a:off x="9880092" y="3399367"/>
-            <a:ext cx="82296" cy="82296"/>
-          </a:xfrm>
-          <a:prstGeom prst="ellipse">
-            <a:avLst/>
-          </a:prstGeom>
-          <a:solidFill>
-            <a:srgbClr val="E9EEF3"/>
-          </a:solidFill>
-          <a:ln>
-            <a:noFill/>
-          </a:ln>
-        </p:spPr>
-        <p:txBody>
-          <a:bodyPr rtlCol="0" anchor="ctr"/>
-          <a:lstStyle/>
-          <a:p>
-            <a:pPr algn="ctr"/>
-          </a:p>
-        </p:txBody>
-      </p:sp>
-      <p:sp>
-        <p:nvSpPr>
-          <p:cNvPr id="26" name="Evidence site"/>
-          <p:cNvSpPr/>
-          <p:nvPr/>
-        </p:nvSpPr>
-        <p:spPr>
-          <a:xfrm>
-            <a:off x="10291572" y="3673687"/>
-            <a:ext cx="82296" cy="82296"/>
-          </a:xfrm>
-          <a:prstGeom prst="ellipse">
-            <a:avLst/>
-          </a:prstGeom>
-          <a:solidFill>
-            <a:srgbClr val="E9EEF3"/>
-          </a:solidFill>
-          <a:ln>
-            <a:noFill/>
-          </a:ln>
-        </p:spPr>
-        <p:txBody>
-          <a:bodyPr rtlCol="0" anchor="ctr"/>
-          <a:lstStyle/>
-          <a:p>
-            <a:pPr algn="ctr"/>
-          </a:p>
-        </p:txBody>
-      </p:sp>
-      <p:sp>
-        <p:nvSpPr>
-          <p:cNvPr id="27" name="Evidence site"/>
-          <p:cNvSpPr/>
-          <p:nvPr/>
-        </p:nvSpPr>
-        <p:spPr>
-          <a:xfrm>
-            <a:off x="9605772" y="3765127"/>
-            <a:ext cx="82296" cy="82296"/>
-          </a:xfrm>
-          <a:prstGeom prst="ellipse">
-            <a:avLst/>
-          </a:prstGeom>
-          <a:solidFill>
-            <a:srgbClr val="E9EEF3"/>
-          </a:solidFill>
-          <a:ln>
-            <a:noFill/>
-          </a:ln>
-        </p:spPr>
-        <p:txBody>
-          <a:bodyPr rtlCol="0" anchor="ctr"/>
-          <a:lstStyle/>
-          <a:p>
-            <a:pPr algn="ctr"/>
-          </a:p>
-        </p:txBody>
-      </p:sp>
-      <p:sp>
-        <p:nvSpPr>
-          <p:cNvPr id="28" name="Evidence site"/>
-          <p:cNvSpPr/>
-          <p:nvPr/>
-        </p:nvSpPr>
-        <p:spPr>
-          <a:xfrm>
-            <a:off x="10474452" y="3170767"/>
-            <a:ext cx="82296" cy="82296"/>
-          </a:xfrm>
-          <a:prstGeom prst="ellipse">
-            <a:avLst/>
-          </a:prstGeom>
-          <a:solidFill>
-            <a:srgbClr val="E9EEF3"/>
-          </a:solidFill>
-          <a:ln>
-            <a:noFill/>
-          </a:ln>
-        </p:spPr>
-        <p:txBody>
-          <a:bodyPr rtlCol="0" anchor="ctr"/>
-          <a:lstStyle/>
-          <a:p>
-            <a:pPr algn="ctr"/>
-          </a:p>
-        </p:txBody>
-      </p:sp>
-      <p:sp>
-        <p:nvSpPr>
-          <p:cNvPr id="29" name="Console"/>
-          <p:cNvSpPr/>
-          <p:nvPr/>
-        </p:nvSpPr>
-        <p:spPr>
-          <a:xfrm>
-            <a:off x="8549640" y="4414180"/>
-            <a:ext cx="2133295" cy="201168"/>
-          </a:xfrm>
-          <a:prstGeom prst="roundRect">
-            <a:avLst>
-              <a:gd name="adj" fmla="val 30000"/>
-            </a:avLst>
-          </a:prstGeom>
-          <a:solidFill>
-            <a:srgbClr val="161C25"/>
-          </a:solidFill>
-          <a:ln w="12700">
-            <a:solidFill>
-              <a:srgbClr val="2E3339"/>
-            </a:solidFill>
-          </a:ln>
-        </p:spPr>
-        <p:txBody>
-          <a:bodyPr rtlCol="0" anchor="ctr"/>
-          <a:lstStyle/>
-          <a:p>
-            <a:pPr algn="ctr"/>
-          </a:p>
-        </p:txBody>
-      </p:sp>
-      <p:sp>
-        <p:nvSpPr>
-          <p:cNvPr id="30" name="Schematic marker 1"/>
-          <p:cNvSpPr/>
-          <p:nvPr/>
-        </p:nvSpPr>
-        <p:spPr>
-          <a:xfrm>
-            <a:off x="7982711" y="2507827"/>
-            <a:ext cx="384048" cy="384048"/>
-          </a:xfrm>
-          <a:prstGeom prst="ellipse">
-            <a:avLst/>
-          </a:prstGeom>
-          <a:solidFill>
-            <a:srgbClr val="1D2530"/>
-          </a:solidFill>
-          <a:ln w="12700">
-            <a:solidFill>
-              <a:srgbClr val="43484F"/>
-            </a:solidFill>
-          </a:ln>
-        </p:spPr>
-        <p:txBody>
-          <a:bodyPr rtlCol="0" anchor="ctr" lIns="0" rIns="0" tIns="0" bIns="0" wrap="none"/>
-          <a:lstStyle/>
-          <a:p>
-            <a:pPr algn="ctr"/>
-            <a:r>
-              <a:rPr sz="2000" b="1" lang="en-GB">
-                <a:solidFill>
-                  <a:srgbClr val="E9EEF3"/>
-                </a:solidFill>
-                <a:latin typeface="Menlo"/>
-                <a:ea typeface="Menlo"/>
-                <a:cs typeface="Menlo"/>
-              </a:rPr>
-              <a:t>1</a:t>
-            </a:r>
-          </a:p>
-        </p:txBody>
-      </p:sp>
-      <p:sp>
-        <p:nvSpPr>
-          <p:cNvPr id="31" name="Schematic marker 2"/>
-          <p:cNvSpPr/>
-          <p:nvPr/>
-        </p:nvSpPr>
-        <p:spPr>
-          <a:xfrm>
-            <a:off x="10826496" y="2580979"/>
-            <a:ext cx="384048" cy="384048"/>
-          </a:xfrm>
-          <a:prstGeom prst="ellipse">
-            <a:avLst/>
-          </a:prstGeom>
-          <a:solidFill>
-            <a:srgbClr val="1D2530"/>
-          </a:solidFill>
-          <a:ln w="12700">
-            <a:solidFill>
-              <a:srgbClr val="43484F"/>
-            </a:solidFill>
-          </a:ln>
-        </p:spPr>
-        <p:txBody>
-          <a:bodyPr rtlCol="0" anchor="ctr" lIns="0" rIns="0" tIns="0" bIns="0" wrap="none"/>
-          <a:lstStyle/>
-          <a:p>
-            <a:pPr algn="ctr"/>
-            <a:r>
-              <a:rPr sz="2000" b="1" lang="en-GB">
-                <a:solidFill>
-                  <a:srgbClr val="E9EEF3"/>
-                </a:solidFill>
-                <a:latin typeface="Menlo"/>
-                <a:ea typeface="Menlo"/>
-                <a:cs typeface="Menlo"/>
-              </a:rPr>
-              <a:t>2</a:t>
-            </a:r>
-          </a:p>
-        </p:txBody>
-      </p:sp>
+        </p:spPr>
+      </p:pic>
     </p:spTree>
   </p:cSld>
   <p:clrMapOvr>

</xml_diff>

<commit_message>
docs(methane): Carbon Mapper and the columns fix in the notes, spec, diagrams and deck; re-recorded watch replay
- Rehearsal notes section 8: the Carbon Mapper line, the follow rule, the honest line, the replay
  line and timing, with a box saying it is on dev v46 only until promoted.
- Spec: requirements 13 and 14, the design (root cause: 14 of 43 missions since Oct 20 had no
  columns display, 8 of 17 on Oct 22), task 26 with the v44, v45 and v46 results.
- Both architecture diagrams gain the Carbon Mapper catalogue; PNG and SVG re-exported.
- Deck slides 5 and 6: new pictures fitted in the old frames, slide 6 "If asked about data" note;
  previews re-rendered.
- use-cases/methane-watch-mission: the take recorded from dev v45 (30 calls, Shanxi followed,
  columns shown, Carbon Mapper none at both cued sites). GeoTIFFs stay gitignored.
- Gallery description mentions the Carbon Mapper cross-check.
</commit_message>
<xml_diff>
--- a/docs/demo/agentic-ai-for-earth-intro.pptx
+++ b/docs/demo/agentic-ai-for-earth-intro.pptx
@@ -950,7 +950,7 @@
                 <a:ea typeface="Atkinson Hyperlegible"/>
                 <a:cs typeface="Atkinson Hyperlegible"/>
               </a:rPr>
-              <a:t>Four acts, one pattern. The Earth Analyst looked at a scene before it measured, and turned down a cloudy one. The AI Archaeologist chose its own line to measure across an Octagon wall. Methane Watch followed a satellite tip, checked it with a sharper instrument, and told us what it could not confirm. Dark Vessels chose its radar pass, checked whether a silence could mean anything there, predicted where to look and drafted a patrol; the officer decided whether it goes. Not every step was the model choosing live: some of the data was prepared ahead of time, and I’ve pointed out which. Each agent is its own runtime on Amazon Bedrock AgentCore, on one shared map. The agent does the legwork and drafts; a person decides. [Your call to action]</a:t>
+              <a:t>Four acts, one pattern. The Earth Analyst looked at a scene before it measured, and turned down a cloudy one. The AI Archaeologist chose its own line to measure across an Octagon wall. Methane Watch followed a satellite tip, checked it with a sharper instrument and an independent catalogue, and told us what it could not confirm. Dark Vessels chose its radar pass, checked whether a silence could mean anything there, predicted where to look and drafted a patrol; the officer decided whether it goes. Not every step was the model choosing live: some of the data was prepared ahead of time, and I’ve pointed out which. Each agent is its own runtime on Amazon Bedrock AgentCore, on one shared map. The agent does the legwork and drafts; a person decides. [Your call to action]</a:t>
             </a:r>
           </a:p>
           <a:p>
@@ -1084,7 +1084,7 @@
                 <a:ea typeface="Atkinson Hyperlegible"/>
                 <a:cs typeface="Atkinson Hyperlegible"/>
               </a:rPr>
-              <a:t>Left to right. The analyst or officer asks in the web app, a React frontend and API backend on AWS Fargate behind Amazon CloudFront. It goes to one of four Strands agents, each on its own AgentCore runtime. Claude Sonnet 4.6 on Amazon Bedrock is the model the agents use. Along the bottom, the data sources: Sentinel-2 imagery, Sentinel-5P methane, Overture Maps and Clay embeddings from AWS Open Data; NASA’s EMIT plumes and FIRMS fires; Esri’s ArcGIS MCP server, OpenStreetMap, ESA’s Sentinel-1 plans, Sentinel-1 radar from Microsoft Planetary Computer, Global Fishing Watch, USGS LiDAR, the OGIM and GEM registries, and our own S3 bucket. Nothing is filed until the analyst or officer approves; then it goes to S3 and Slack.</a:t>
+              <a:t>Left to right. The analyst or officer asks in the web app, a React frontend and API backend on AWS Fargate behind Amazon CloudFront. It goes to one of four Strands agents, each on its own AgentCore runtime. Claude Sonnet 4.6 on Amazon Bedrock is the model the agents use. Along the bottom, the data sources: Sentinel-2 imagery, Sentinel-5P methane, Overture Maps and Clay embeddings from AWS Open Data; NASA’s EMIT plumes and FIRMS fires; Esri’s ArcGIS MCP server, OpenStreetMap, ESA’s Sentinel-1 plans, Sentinel-1 radar from Microsoft Planetary Computer, Global Fishing Watch, USGS LiDAR, the OGIM and GEM registries, Carbon Mapper’s public plume catalogue, and our own S3 bucket. Nothing is filed until the analyst or officer approves; then it goes to S3 and Slack.</a:t>
             </a:r>
           </a:p>
           <a:p>
@@ -1287,7 +1287,7 @@
                 <a:ea typeface="Atkinson Hyperlegible"/>
                 <a:cs typeface="Atkinson Hyperlegible"/>
               </a:rPr>
-              <a:t>The agents read Sentinel-2 from AWS Open Data, the Clay embeddings through a Lambda fan-out with DuckDB, Esri’s ArcGIS MCP server, OpenStreetMap and ESA’s Sentinel-1 plans when asked. The methane data, Sentinel-5P from AWS Open Data with NASA EMIT and FIRMS, is warmed into S3 the day before and on the day, and fetched only if something is missing. The radar and AIS from Microsoft Planetary Computer and Global Fishing Watch, the USGS 3DEP LiDAR and the OGIM and GEM registries are built into S3 by scripts before the show, so the agents never call those providers during it.</a:t>
+              <a:t>The agents read Sentinel-2 from AWS Open Data, the Clay embeddings through a Lambda fan-out with DuckDB, Esri’s ArcGIS MCP server, OpenStreetMap and ESA’s Sentinel-1 plans when asked. The methane data, Sentinel-5P from AWS Open Data with NASA EMIT and FIRMS and Carbon Mapper’s public plumes (the Tanager-1 satellite and EMIT, from data.carbonmapper.org, credited on the stage), is warmed into S3 the day before and on the day, and fetched only if something is missing. The radar and AIS from Microsoft Planetary Computer and Global Fishing Watch, the USGS 3DEP LiDAR and the OGIM and GEM registries are built into S3 by scripts before the show, so the agents never call those providers during it.</a:t>
             </a:r>
           </a:p>
           <a:p>
@@ -6231,7 +6231,7 @@
       </p:sp>
       <p:pic>
         <p:nvPicPr>
-          <p:cNvPr id="4" name="Architecture diagram" descr="Architecture, left to right. The analyst or officer asks and approves in the web app: Amazon CloudFront in front of a React frontend and API backend on AWS Fargate. The web app invokes four agents in one Amazon Bedrock AgentCore group, one runtime each: Earth Analyst, AI Archaeologist, Methane Hunter and Dark Vessels. The agents make model calls to Claude Sonnet 4.6, in its own Amazon Bedrock box. The agents read the data sources: Amazon S3 sessions and caches; NASA EMIT methane plumes and FIRMS active fires; AWS Open Data Sentinel-2 imagery, Sentinel-5P methane, Overture Maps and Clay v1.5 embeddings via a Lambda fan-out; and other providers: Esri ArcGIS MCP server, OpenStreetMap, ESA Sentinel-1 plans, Global Fishing Watch, USGS 3DEP LiDAR, OGIM and GEM registries, and Sentinel-1 radar via Microsoft Planetary Computer. On approval the web app files to Amazon S3 and posts to Slack."/>
+          <p:cNvPr id="4" name="Architecture diagram" descr="Architecture, left to right. The analyst or officer asks and approves in the web app: Amazon CloudFront in front of a React frontend and API backend on AWS Fargate. The web app invokes four agents in one Amazon Bedrock AgentCore group, one runtime each: Earth Analyst, AI Archaeologist, Methane Hunter and Dark Vessels. The agents make model calls to Claude Sonnet 4.6, in its own Amazon Bedrock box. The agents read the data sources: Amazon S3 sessions and caches; NASA EMIT methane plumes and FIRMS active fires; AWS Open Data Sentinel-2 imagery, Sentinel-5P methane, Overture Maps and Clay v1.5 embeddings via a Lambda fan-out; and other providers: Esri ArcGIS MCP server, OpenStreetMap, ESA Sentinel-1 plans, Global Fishing Watch, Carbon Mapper plumes, USGS 3DEP LiDAR, OGIM and GEM registries, and Sentinel-1 radar via Microsoft Planetary Computer. On approval the web app files to Amazon S3 and posts to Slack."/>
           <p:cNvPicPr>
             <a:picLocks noChangeAspect="1"/>
           </p:cNvPicPr>
@@ -6245,8 +6245,8 @@
         </p:blipFill>
         <p:spPr>
           <a:xfrm>
-            <a:off x="335279" y="1426464"/>
-            <a:ext cx="11521440" cy="5030377"/>
+            <a:off x="599846" y="1426464"/>
+            <a:ext cx="10992305" cy="5030377"/>
           </a:xfrm>
           <a:prstGeom prst="rect">
             <a:avLst/>
@@ -6378,7 +6378,7 @@
       </p:sp>
       <p:pic>
         <p:nvPicPr>
-          <p:cNvPr id="4" name="Detailed architecture diagram" descr="Detailed architecture. The analyst or officer signs in with Amazon Cognito, loads map tiles from the tile server (Amazon API Gateway and TiTiler on AWS Lambda), and asks and approves through the web app: CloudFront with AWS WAF, an Application Load Balancer, and Amazon ECS on AWS Fargate serving the React frontend and the Express API backend, with the Slack webhook URL from AWS Secrets Manager. The web app invokes four runtimes in the Amazon Bedrock AgentCore group, each a Strands agent with its main tools; they make model calls to Claude Sonnet 4.6 in its own Amazon Bedrock box. The S3 project bucket holds session files and filed briefs and taskings. Data sources by provider: AWS Open Data (Sentinel-2, Sentinel-5P, Overture Maps, Clay embeddings through a Lambda fan-out), NASA (EMIT, FIRMS), other providers (Esri ArcGIS MCP server, OpenStreetMap, ESA Sentinel-1 plans, Sentinel-1 radar from Microsoft Planetary Computer, Global Fishing Watch, USGS 3DEP LiDAR, OGIM and GEM), and Amazon S3 caches written by build scripts. Filed decisions post to Slack."/>
+          <p:cNvPr id="4" name="Detailed architecture diagram" descr="Detailed architecture. The analyst or officer signs in with Amazon Cognito, loads map tiles from the tile server (Amazon API Gateway and TiTiler on AWS Lambda), and asks and approves through the web app: CloudFront with AWS WAF, an Application Load Balancer, and Amazon ECS on AWS Fargate serving the React frontend and the Express API backend, with the Slack webhook URL from AWS Secrets Manager. The web app invokes four runtimes in the Amazon Bedrock AgentCore group, each a Strands agent with its main tools; they make model calls to Claude Sonnet 4.6 in its own Amazon Bedrock box. The S3 project bucket holds session files and filed briefs and taskings. Data sources by provider: AWS Open Data (Sentinel-2, Sentinel-5P, Overture Maps, Clay embeddings through a Lambda fan-out), NASA (EMIT, FIRMS), other providers (Esri ArcGIS MCP server, OpenStreetMap, ESA Sentinel-1 plans, Sentinel-1 radar from Microsoft Planetary Computer, Global Fishing Watch, USGS 3DEP LiDAR, OGIM and GEM, Carbon Mapper), and Amazon S3 caches written by build scripts. Filed decisions post to Slack."/>
           <p:cNvPicPr>
             <a:picLocks noChangeAspect="1"/>
           </p:cNvPicPr>
@@ -6392,8 +6392,8 @@
         </p:blipFill>
         <p:spPr>
           <a:xfrm>
-            <a:off x="512064" y="1060704"/>
-            <a:ext cx="11164824" cy="5151508"/>
+            <a:off x="623537" y="1060704"/>
+            <a:ext cx="10941878" cy="5151508"/>
           </a:xfrm>
           <a:prstGeom prst="rect">
             <a:avLst/>

</xml_diff>